<commit_message>
redesign v3: Light green professional theme, neutral (no Recommended labels)
Changes from feedback:
- REMOVED all 'Recommended' labels — both options presented equally
- ADDED dedicated Option 1 slide (CP Goa detailed) — Slide 3
- CHANGED color scheme: Light professional green (#0D7C5F) instead of dark
- White/light backgrounds throughout (not dark)
- Green title slide with white floating card
- Navy blue for Option 1 differentiation
- Clean, modern, bright aesthetic

Slides:
1. The Challenge (green bg + white card)
2. Two Solutions side-by-side (equal weight)
3. Option 1: CP Goa detailed (navy header)
4. Option 2: Goa Coastal Resorts detailed (green header)
5. Website & Commercial (green pricing card)
</commit_message>
<xml_diff>
--- a/Casino_Pride_Digital_Strategy.pptx
+++ b/Casino_Pride_Digital_Strategy.pptx
@@ -1213,7 +1213,7 @@
     <p:bg>
       <p:bgPr>
         <a:solidFill>
-          <a:srgbClr val="0A0E1A"/>
+          <a:srgbClr val="0D7C5F"/>
         </a:solidFill>
       </p:bgPr>
     </p:bg>
@@ -1239,14 +1239,14 @@
         </p:nvSpPr>
         <p:spPr>
           <a:xfrm>
-            <a:off x="-1371600" y="-1371600"/>
-            <a:ext cx="4114800" cy="4114800"/>
+            <a:off x="5943600" y="-1371600"/>
+            <a:ext cx="5029200" cy="5029200"/>
           </a:xfrm>
           <a:prstGeom prst="ellipse">
             <a:avLst/>
           </a:prstGeom>
           <a:solidFill>
-            <a:srgbClr val="141B2D"/>
+            <a:srgbClr val="065F46"/>
           </a:solidFill>
           <a:ln/>
         </p:spPr>
@@ -1259,8 +1259,28 @@
         </p:nvSpPr>
         <p:spPr>
           <a:xfrm>
+            <a:off x="7772400" y="3200400"/>
+            <a:ext cx="2286000" cy="2286000"/>
+          </a:xfrm>
+          <a:prstGeom prst="ellipse">
+            <a:avLst/>
+          </a:prstGeom>
+          <a:solidFill>
+            <a:srgbClr val="065F46"/>
+          </a:solidFill>
+          <a:ln/>
+        </p:spPr>
+      </p:sp>
+      <p:sp>
+        <p:nvSpPr>
+          <p:cNvPr id="4" name="Shape 2"/>
+          <p:cNvSpPr/>
+          <p:nvPr/>
+        </p:nvSpPr>
+        <p:spPr>
+          <a:xfrm>
             <a:off x="548640" y="457200"/>
-            <a:ext cx="1463040" cy="292608"/>
+            <a:ext cx="1554480" cy="292608"/>
           </a:xfrm>
           <a:prstGeom prst="roundRect">
             <a:avLst>
@@ -1268,21 +1288,21 @@
             </a:avLst>
           </a:prstGeom>
           <a:solidFill>
-            <a:srgbClr val="8B7535"/>
-          </a:solidFill>
-          <a:ln/>
-        </p:spPr>
-      </p:sp>
-      <p:sp>
-        <p:nvSpPr>
-          <p:cNvPr id="4" name="Text 2"/>
+            <a:srgbClr val="FFFFFF"/>
+          </a:solidFill>
+          <a:ln/>
+        </p:spPr>
+      </p:sp>
+      <p:sp>
+        <p:nvSpPr>
+          <p:cNvPr id="5" name="Text 3"/>
           <p:cNvSpPr/>
           <p:nvPr/>
         </p:nvSpPr>
         <p:spPr>
           <a:xfrm>
             <a:off x="548640" y="457200"/>
-            <a:ext cx="1463040" cy="292608"/>
+            <a:ext cx="1554480" cy="292608"/>
           </a:xfrm>
           <a:prstGeom prst="rect">
             <a:avLst/>
@@ -1300,7 +1320,7 @@
             <a:r>
               <a:rPr lang="en-US" sz="800" b="1" spc="150" kern="0" dirty="0">
                 <a:solidFill>
-                  <a:srgbClr val="FFFFFF"/>
+                  <a:srgbClr val="065F46"/>
                 </a:solidFill>
                 <a:latin typeface="Calibri" pitchFamily="34" charset="0"/>
                 <a:ea typeface="Calibri" pitchFamily="34" charset="-122"/>
@@ -1314,14 +1334,14 @@
       </p:sp>
       <p:sp>
         <p:nvSpPr>
-          <p:cNvPr id="5" name="Text 3"/>
+          <p:cNvPr id="6" name="Text 4"/>
           <p:cNvSpPr/>
           <p:nvPr/>
         </p:nvSpPr>
         <p:spPr>
           <a:xfrm>
             <a:off x="548640" y="1005840"/>
-            <a:ext cx="5029200" cy="1645920"/>
+            <a:ext cx="5303520" cy="1645920"/>
           </a:xfrm>
           <a:prstGeom prst="rect">
             <a:avLst/>
@@ -1396,14 +1416,14 @@
       </p:sp>
       <p:sp>
         <p:nvSpPr>
-          <p:cNvPr id="6" name="Text 4"/>
+          <p:cNvPr id="7" name="Text 5"/>
           <p:cNvSpPr/>
           <p:nvPr/>
         </p:nvSpPr>
         <p:spPr>
           <a:xfrm>
             <a:off x="548640" y="2834640"/>
-            <a:ext cx="4754880" cy="777240"/>
+            <a:ext cx="4937760" cy="777240"/>
           </a:xfrm>
           <a:prstGeom prst="rect">
             <a:avLst/>
@@ -1424,7 +1444,7 @@
             <a:r>
               <a:rPr lang="en-US" sz="1050" dirty="0">
                 <a:solidFill>
-                  <a:srgbClr val="9CA3AF"/>
+                  <a:srgbClr val="D1FAE5"/>
                 </a:solidFill>
                 <a:latin typeface="Calibri" pitchFamily="34" charset="0"/>
                 <a:ea typeface="Calibri" pitchFamily="34" charset="-122"/>
@@ -1438,14 +1458,14 @@
       </p:sp>
       <p:sp>
         <p:nvSpPr>
-          <p:cNvPr id="7" name="Text 5"/>
+          <p:cNvPr id="8" name="Text 6"/>
           <p:cNvSpPr/>
           <p:nvPr/>
         </p:nvSpPr>
         <p:spPr>
           <a:xfrm>
             <a:off x="548640" y="3703320"/>
-            <a:ext cx="4754880" cy="640080"/>
+            <a:ext cx="4937760" cy="594360"/>
           </a:xfrm>
           <a:prstGeom prst="rect">
             <a:avLst/>
@@ -1466,7 +1486,7 @@
             <a:r>
               <a:rPr lang="en-US" sz="1050" dirty="0">
                 <a:solidFill>
-                  <a:srgbClr val="9CA3AF"/>
+                  <a:srgbClr val="D1FAE5"/>
                 </a:solidFill>
                 <a:latin typeface="Calibri" pitchFamily="34" charset="0"/>
                 <a:ea typeface="Calibri" pitchFamily="34" charset="-122"/>
@@ -1480,28 +1500,28 @@
       </p:sp>
       <p:sp>
         <p:nvSpPr>
-          <p:cNvPr id="8" name="Shape 6"/>
-          <p:cNvSpPr/>
-          <p:nvPr/>
-        </p:nvSpPr>
-        <p:spPr>
-          <a:xfrm>
-            <a:off x="5669280" y="731520"/>
-            <a:ext cx="3108960" cy="3840480"/>
+          <p:cNvPr id="9" name="Shape 7"/>
+          <p:cNvSpPr/>
+          <p:nvPr/>
+        </p:nvSpPr>
+        <p:spPr>
+          <a:xfrm>
+            <a:off x="5760720" y="914400"/>
+            <a:ext cx="3017520" cy="3474720"/>
           </a:xfrm>
           <a:prstGeom prst="roundRect">
             <a:avLst>
-              <a:gd name="adj" fmla="val 4412"/>
+              <a:gd name="adj" fmla="val 4545"/>
             </a:avLst>
           </a:prstGeom>
           <a:solidFill>
-            <a:srgbClr val="141B2D"/>
+            <a:srgbClr val="FFFFFF"/>
           </a:solidFill>
           <a:ln/>
           <a:effectLst>
-            <a:outerShdw sx="100000" sy="100000" kx="0" ky="0" algn="bl" rotWithShape="0" blurRad="152400" dist="50800" dir="16200000">
+            <a:outerShdw sx="100000" sy="100000" kx="0" ky="0" algn="bl" rotWithShape="0" blurRad="127000" dist="38100" dir="16200000">
               <a:srgbClr val="000000">
-                <a:alpha val="30000"/>
+                <a:alpha val="15000"/>
               </a:srgbClr>
             </a:outerShdw>
           </a:effectLst>
@@ -1509,14 +1529,14 @@
       </p:sp>
       <p:sp>
         <p:nvSpPr>
-          <p:cNvPr id="9" name="Shape 7"/>
-          <p:cNvSpPr/>
-          <p:nvPr/>
-        </p:nvSpPr>
-        <p:spPr>
-          <a:xfrm>
-            <a:off x="5943600" y="960120"/>
-            <a:ext cx="1828800" cy="36576"/>
+          <p:cNvPr id="10" name="Shape 8"/>
+          <p:cNvSpPr/>
+          <p:nvPr/>
+        </p:nvSpPr>
+        <p:spPr>
+          <a:xfrm>
+            <a:off x="6035040" y="1143000"/>
+            <a:ext cx="1645920" cy="36576"/>
           </a:xfrm>
           <a:prstGeom prst="roundRect">
             <a:avLst>
@@ -1524,21 +1544,21 @@
             </a:avLst>
           </a:prstGeom>
           <a:solidFill>
-            <a:srgbClr val="D4A853"/>
-          </a:solidFill>
-          <a:ln/>
-        </p:spPr>
-      </p:sp>
-      <p:sp>
-        <p:nvSpPr>
-          <p:cNvPr id="10" name="Text 8"/>
-          <p:cNvSpPr/>
-          <p:nvPr/>
-        </p:nvSpPr>
-        <p:spPr>
-          <a:xfrm>
-            <a:off x="5943600" y="1143000"/>
-            <a:ext cx="2560320" cy="365760"/>
+            <a:srgbClr val="34D399"/>
+          </a:solidFill>
+          <a:ln/>
+        </p:spPr>
+      </p:sp>
+      <p:sp>
+        <p:nvSpPr>
+          <p:cNvPr id="11" name="Text 9"/>
+          <p:cNvSpPr/>
+          <p:nvPr/>
+        </p:nvSpPr>
+        <p:spPr>
+          <a:xfrm>
+            <a:off x="6035040" y="1325880"/>
+            <a:ext cx="2468880" cy="365760"/>
           </a:xfrm>
           <a:prstGeom prst="rect">
             <a:avLst/>
@@ -1556,7 +1576,7 @@
             <a:r>
               <a:rPr lang="en-US" sz="1400" b="1" dirty="0">
                 <a:solidFill>
-                  <a:srgbClr val="FFFFFF"/>
+                  <a:srgbClr val="065F46"/>
                 </a:solidFill>
                 <a:latin typeface="Cambria" pitchFamily="34" charset="0"/>
                 <a:ea typeface="Cambria" pitchFamily="34" charset="-122"/>
@@ -1570,14 +1590,14 @@
       </p:sp>
       <p:sp>
         <p:nvSpPr>
-          <p:cNvPr id="11" name="Text 9"/>
-          <p:cNvSpPr/>
-          <p:nvPr/>
-        </p:nvSpPr>
-        <p:spPr>
-          <a:xfrm>
-            <a:off x="5943600" y="1554480"/>
-            <a:ext cx="2560320" cy="502920"/>
+          <p:cNvPr id="12" name="Text 10"/>
+          <p:cNvSpPr/>
+          <p:nvPr/>
+        </p:nvSpPr>
+        <p:spPr>
+          <a:xfrm>
+            <a:off x="6035040" y="1737360"/>
+            <a:ext cx="2468880" cy="457200"/>
           </a:xfrm>
           <a:prstGeom prst="rect">
             <a:avLst/>
@@ -1598,7 +1618,7 @@
             <a:r>
               <a:rPr lang="en-US" sz="1000" dirty="0">
                 <a:solidFill>
-                  <a:srgbClr val="9CA3AF"/>
+                  <a:srgbClr val="4B5563"/>
                 </a:solidFill>
                 <a:latin typeface="Calibri" pitchFamily="34" charset="0"/>
                 <a:ea typeface="Calibri" pitchFamily="34" charset="-122"/>
@@ -1612,34 +1632,34 @@
       </p:sp>
       <p:sp>
         <p:nvSpPr>
-          <p:cNvPr id="12" name="Shape 10"/>
-          <p:cNvSpPr/>
-          <p:nvPr/>
-        </p:nvSpPr>
-        <p:spPr>
-          <a:xfrm>
-            <a:off x="5943600" y="2267712"/>
-            <a:ext cx="109728" cy="109728"/>
+          <p:cNvPr id="13" name="Shape 11"/>
+          <p:cNvSpPr/>
+          <p:nvPr/>
+        </p:nvSpPr>
+        <p:spPr>
+          <a:xfrm>
+            <a:off x="6035040" y="2350008"/>
+            <a:ext cx="128016" cy="128016"/>
           </a:xfrm>
           <a:prstGeom prst="ellipse">
             <a:avLst/>
           </a:prstGeom>
           <a:solidFill>
-            <a:srgbClr val="D4A853"/>
-          </a:solidFill>
-          <a:ln/>
-        </p:spPr>
-      </p:sp>
-      <p:sp>
-        <p:nvSpPr>
-          <p:cNvPr id="13" name="Text 11"/>
-          <p:cNvSpPr/>
-          <p:nvPr/>
-        </p:nvSpPr>
-        <p:spPr>
-          <a:xfrm>
-            <a:off x="6217920" y="2194560"/>
-            <a:ext cx="2286000" cy="274320"/>
+            <a:srgbClr val="34D399"/>
+          </a:solidFill>
+          <a:ln/>
+        </p:spPr>
+      </p:sp>
+      <p:sp>
+        <p:nvSpPr>
+          <p:cNvPr id="14" name="Text 12"/>
+          <p:cNvSpPr/>
+          <p:nvPr/>
+        </p:nvSpPr>
+        <p:spPr>
+          <a:xfrm>
+            <a:off x="6309360" y="2286000"/>
+            <a:ext cx="2194560" cy="274320"/>
           </a:xfrm>
           <a:prstGeom prst="rect">
             <a:avLst/>
@@ -1657,7 +1677,7 @@
             <a:r>
               <a:rPr lang="en-US" sz="1200" b="1" dirty="0">
                 <a:solidFill>
-                  <a:srgbClr val="FFFFFF"/>
+                  <a:srgbClr val="1F2937"/>
                 </a:solidFill>
                 <a:latin typeface="Calibri" pitchFamily="34" charset="0"/>
                 <a:ea typeface="Calibri" pitchFamily="34" charset="-122"/>
@@ -1671,34 +1691,34 @@
       </p:sp>
       <p:sp>
         <p:nvSpPr>
-          <p:cNvPr id="14" name="Shape 12"/>
-          <p:cNvSpPr/>
-          <p:nvPr/>
-        </p:nvSpPr>
-        <p:spPr>
-          <a:xfrm>
-            <a:off x="5943600" y="2651760"/>
-            <a:ext cx="109728" cy="109728"/>
+          <p:cNvPr id="15" name="Shape 13"/>
+          <p:cNvSpPr/>
+          <p:nvPr/>
+        </p:nvSpPr>
+        <p:spPr>
+          <a:xfrm>
+            <a:off x="6035040" y="2734056"/>
+            <a:ext cx="128016" cy="128016"/>
           </a:xfrm>
           <a:prstGeom prst="ellipse">
             <a:avLst/>
           </a:prstGeom>
           <a:solidFill>
-            <a:srgbClr val="D4A853"/>
-          </a:solidFill>
-          <a:ln/>
-        </p:spPr>
-      </p:sp>
-      <p:sp>
-        <p:nvSpPr>
-          <p:cNvPr id="15" name="Text 13"/>
-          <p:cNvSpPr/>
-          <p:nvPr/>
-        </p:nvSpPr>
-        <p:spPr>
-          <a:xfrm>
-            <a:off x="6217920" y="2578608"/>
-            <a:ext cx="2286000" cy="274320"/>
+            <a:srgbClr val="34D399"/>
+          </a:solidFill>
+          <a:ln/>
+        </p:spPr>
+      </p:sp>
+      <p:sp>
+        <p:nvSpPr>
+          <p:cNvPr id="16" name="Text 14"/>
+          <p:cNvSpPr/>
+          <p:nvPr/>
+        </p:nvSpPr>
+        <p:spPr>
+          <a:xfrm>
+            <a:off x="6309360" y="2670048"/>
+            <a:ext cx="2194560" cy="274320"/>
           </a:xfrm>
           <a:prstGeom prst="rect">
             <a:avLst/>
@@ -1716,7 +1736,7 @@
             <a:r>
               <a:rPr lang="en-US" sz="1200" b="1" dirty="0">
                 <a:solidFill>
-                  <a:srgbClr val="FFFFFF"/>
+                  <a:srgbClr val="1F2937"/>
                 </a:solidFill>
                 <a:latin typeface="Calibri" pitchFamily="34" charset="0"/>
                 <a:ea typeface="Calibri" pitchFamily="34" charset="-122"/>
@@ -1730,34 +1750,34 @@
       </p:sp>
       <p:sp>
         <p:nvSpPr>
-          <p:cNvPr id="16" name="Shape 14"/>
-          <p:cNvSpPr/>
-          <p:nvPr/>
-        </p:nvSpPr>
-        <p:spPr>
-          <a:xfrm>
-            <a:off x="5943600" y="3035808"/>
-            <a:ext cx="109728" cy="109728"/>
+          <p:cNvPr id="17" name="Shape 15"/>
+          <p:cNvSpPr/>
+          <p:nvPr/>
+        </p:nvSpPr>
+        <p:spPr>
+          <a:xfrm>
+            <a:off x="6035040" y="3118104"/>
+            <a:ext cx="128016" cy="128016"/>
           </a:xfrm>
           <a:prstGeom prst="ellipse">
             <a:avLst/>
           </a:prstGeom>
           <a:solidFill>
-            <a:srgbClr val="D4A853"/>
-          </a:solidFill>
-          <a:ln/>
-        </p:spPr>
-      </p:sp>
-      <p:sp>
-        <p:nvSpPr>
-          <p:cNvPr id="17" name="Text 15"/>
-          <p:cNvSpPr/>
-          <p:nvPr/>
-        </p:nvSpPr>
-        <p:spPr>
-          <a:xfrm>
-            <a:off x="6217920" y="2962656"/>
-            <a:ext cx="2286000" cy="274320"/>
+            <a:srgbClr val="34D399"/>
+          </a:solidFill>
+          <a:ln/>
+        </p:spPr>
+      </p:sp>
+      <p:sp>
+        <p:nvSpPr>
+          <p:cNvPr id="18" name="Text 16"/>
+          <p:cNvSpPr/>
+          <p:nvPr/>
+        </p:nvSpPr>
+        <p:spPr>
+          <a:xfrm>
+            <a:off x="6309360" y="3054096"/>
+            <a:ext cx="2194560" cy="274320"/>
           </a:xfrm>
           <a:prstGeom prst="rect">
             <a:avLst/>
@@ -1775,7 +1795,7 @@
             <a:r>
               <a:rPr lang="en-US" sz="1200" b="1" dirty="0">
                 <a:solidFill>
-                  <a:srgbClr val="FFFFFF"/>
+                  <a:srgbClr val="1F2937"/>
                 </a:solidFill>
                 <a:latin typeface="Calibri" pitchFamily="34" charset="0"/>
                 <a:ea typeface="Calibri" pitchFamily="34" charset="-122"/>
@@ -1789,34 +1809,34 @@
       </p:sp>
       <p:sp>
         <p:nvSpPr>
-          <p:cNvPr id="18" name="Shape 16"/>
-          <p:cNvSpPr/>
-          <p:nvPr/>
-        </p:nvSpPr>
-        <p:spPr>
-          <a:xfrm>
-            <a:off x="5943600" y="3419856"/>
-            <a:ext cx="109728" cy="109728"/>
+          <p:cNvPr id="19" name="Shape 17"/>
+          <p:cNvSpPr/>
+          <p:nvPr/>
+        </p:nvSpPr>
+        <p:spPr>
+          <a:xfrm>
+            <a:off x="6035040" y="3502152"/>
+            <a:ext cx="128016" cy="128016"/>
           </a:xfrm>
           <a:prstGeom prst="ellipse">
             <a:avLst/>
           </a:prstGeom>
           <a:solidFill>
-            <a:srgbClr val="D4A853"/>
-          </a:solidFill>
-          <a:ln/>
-        </p:spPr>
-      </p:sp>
-      <p:sp>
-        <p:nvSpPr>
-          <p:cNvPr id="19" name="Text 17"/>
-          <p:cNvSpPr/>
-          <p:nvPr/>
-        </p:nvSpPr>
-        <p:spPr>
-          <a:xfrm>
-            <a:off x="6217920" y="3346704"/>
-            <a:ext cx="2286000" cy="274320"/>
+            <a:srgbClr val="34D399"/>
+          </a:solidFill>
+          <a:ln/>
+        </p:spPr>
+      </p:sp>
+      <p:sp>
+        <p:nvSpPr>
+          <p:cNvPr id="20" name="Text 18"/>
+          <p:cNvSpPr/>
+          <p:nvPr/>
+        </p:nvSpPr>
+        <p:spPr>
+          <a:xfrm>
+            <a:off x="6309360" y="3438144"/>
+            <a:ext cx="2194560" cy="274320"/>
           </a:xfrm>
           <a:prstGeom prst="rect">
             <a:avLst/>
@@ -1834,7 +1854,7 @@
             <a:r>
               <a:rPr lang="en-US" sz="1200" b="1" dirty="0">
                 <a:solidFill>
-                  <a:srgbClr val="FFFFFF"/>
+                  <a:srgbClr val="1F2937"/>
                 </a:solidFill>
                 <a:latin typeface="Calibri" pitchFamily="34" charset="0"/>
                 <a:ea typeface="Calibri" pitchFamily="34" charset="-122"/>
@@ -1848,34 +1868,34 @@
       </p:sp>
       <p:sp>
         <p:nvSpPr>
-          <p:cNvPr id="20" name="Shape 18"/>
-          <p:cNvSpPr/>
-          <p:nvPr/>
-        </p:nvSpPr>
-        <p:spPr>
-          <a:xfrm>
-            <a:off x="5943600" y="3803904"/>
-            <a:ext cx="109728" cy="109728"/>
+          <p:cNvPr id="21" name="Shape 19"/>
+          <p:cNvSpPr/>
+          <p:nvPr/>
+        </p:nvSpPr>
+        <p:spPr>
+          <a:xfrm>
+            <a:off x="6035040" y="3886200"/>
+            <a:ext cx="128016" cy="128016"/>
           </a:xfrm>
           <a:prstGeom prst="ellipse">
             <a:avLst/>
           </a:prstGeom>
           <a:solidFill>
-            <a:srgbClr val="D4A853"/>
-          </a:solidFill>
-          <a:ln/>
-        </p:spPr>
-      </p:sp>
-      <p:sp>
-        <p:nvSpPr>
-          <p:cNvPr id="21" name="Text 19"/>
-          <p:cNvSpPr/>
-          <p:nvPr/>
-        </p:nvSpPr>
-        <p:spPr>
-          <a:xfrm>
-            <a:off x="6217920" y="3730752"/>
-            <a:ext cx="2286000" cy="274320"/>
+            <a:srgbClr val="34D399"/>
+          </a:solidFill>
+          <a:ln/>
+        </p:spPr>
+      </p:sp>
+      <p:sp>
+        <p:nvSpPr>
+          <p:cNvPr id="22" name="Text 20"/>
+          <p:cNvSpPr/>
+          <p:nvPr/>
+        </p:nvSpPr>
+        <p:spPr>
+          <a:xfrm>
+            <a:off x="6309360" y="3822192"/>
+            <a:ext cx="2194560" cy="274320"/>
           </a:xfrm>
           <a:prstGeom prst="rect">
             <a:avLst/>
@@ -1893,7 +1913,7 @@
             <a:r>
               <a:rPr lang="en-US" sz="1200" b="1" dirty="0">
                 <a:solidFill>
-                  <a:srgbClr val="FFFFFF"/>
+                  <a:srgbClr val="1F2937"/>
                 </a:solidFill>
                 <a:latin typeface="Calibri" pitchFamily="34" charset="0"/>
                 <a:ea typeface="Calibri" pitchFamily="34" charset="-122"/>
@@ -1907,7 +1927,7 @@
       </p:sp>
       <p:sp>
         <p:nvSpPr>
-          <p:cNvPr id="22" name="Text 20"/>
+          <p:cNvPr id="23" name="Text 21"/>
           <p:cNvSpPr/>
           <p:nvPr/>
         </p:nvSpPr>
@@ -1932,7 +1952,7 @@
             <a:r>
               <a:rPr lang="en-US" sz="750" i="1" dirty="0">
                 <a:solidFill>
-                  <a:srgbClr val="4B5563"/>
+                  <a:srgbClr val="D1FAE5"/>
                 </a:solidFill>
                 <a:latin typeface="Calibri" pitchFamily="34" charset="0"/>
                 <a:ea typeface="Calibri" pitchFamily="34" charset="-122"/>
@@ -1958,7 +1978,7 @@
     <p:bg>
       <p:bgPr>
         <a:solidFill>
-          <a:srgbClr val="F8FAFC"/>
+          <a:srgbClr val="F8FAF9"/>
         </a:solidFill>
       </p:bgPr>
     </p:bg>
@@ -1993,7 +2013,7 @@
             </a:avLst>
           </a:prstGeom>
           <a:solidFill>
-            <a:srgbClr val="0A0E1A"/>
+            <a:srgbClr val="0D7C5F"/>
           </a:solidFill>
           <a:ln/>
         </p:spPr>
@@ -2056,7 +2076,12 @@
           <a:solidFill>
             <a:srgbClr val="FFFFFF"/>
           </a:solidFill>
-          <a:ln/>
+          <a:ln w="12700">
+            <a:solidFill>
+              <a:srgbClr val="E5E7EB"/>
+            </a:solidFill>
+            <a:prstDash val="solid"/>
+          </a:ln>
           <a:effectLst>
             <a:outerShdw sx="100000" sy="100000" kx="0" ky="0" algn="bl" rotWithShape="0" blurRad="101600" dist="25400" dir="16200000">
               <a:srgbClr val="000000">
@@ -2083,7 +2108,7 @@
             </a:avLst>
           </a:prstGeom>
           <a:solidFill>
-            <a:srgbClr val="3B82F6"/>
+            <a:srgbClr val="2D5A8B"/>
           </a:solidFill>
           <a:ln/>
         </p:spPr>
@@ -2240,7 +2265,7 @@
             <a:avLst/>
           </a:prstGeom>
           <a:solidFill>
-            <a:srgbClr val="3B82F6"/>
+            <a:srgbClr val="2D5A8B"/>
           </a:solidFill>
           <a:ln/>
         </p:spPr>
@@ -2299,7 +2324,7 @@
             <a:avLst/>
           </a:prstGeom>
           <a:solidFill>
-            <a:srgbClr val="3B82F6"/>
+            <a:srgbClr val="2D5A8B"/>
           </a:solidFill>
           <a:ln/>
         </p:spPr>
@@ -2358,7 +2383,7 @@
             <a:avLst/>
           </a:prstGeom>
           <a:solidFill>
-            <a:srgbClr val="3B82F6"/>
+            <a:srgbClr val="2D5A8B"/>
           </a:solidFill>
           <a:ln/>
         </p:spPr>
@@ -2417,7 +2442,7 @@
             <a:avLst/>
           </a:prstGeom>
           <a:solidFill>
-            <a:srgbClr val="3B82F6"/>
+            <a:srgbClr val="2D5A8B"/>
           </a:solidFill>
           <a:ln/>
         </p:spPr>
@@ -2476,7 +2501,7 @@
             <a:avLst/>
           </a:prstGeom>
           <a:solidFill>
-            <a:srgbClr val="3B82F6"/>
+            <a:srgbClr val="2D5A8B"/>
           </a:solidFill>
           <a:ln/>
         </p:spPr>
@@ -2639,16 +2664,16 @@
           <a:solidFill>
             <a:srgbClr val="FFFFFF"/>
           </a:solidFill>
-          <a:ln w="19050">
+          <a:ln w="12700">
             <a:solidFill>
-              <a:srgbClr val="10B981"/>
+              <a:srgbClr val="E5E7EB"/>
             </a:solidFill>
             <a:prstDash val="solid"/>
           </a:ln>
           <a:effectLst>
-            <a:outerShdw sx="100000" sy="100000" kx="0" ky="0" algn="bl" rotWithShape="0" blurRad="127000" dist="38100" dir="16200000">
+            <a:outerShdw sx="100000" sy="100000" kx="0" ky="0" algn="bl" rotWithShape="0" blurRad="101600" dist="25400" dir="16200000">
               <a:srgbClr val="000000">
-                <a:alpha val="10000"/>
+                <a:alpha val="8000"/>
               </a:srgbClr>
             </a:outerShdw>
           </a:effectLst>
@@ -2663,7 +2688,7 @@
         <p:spPr>
           <a:xfrm>
             <a:off x="4937760" y="1097280"/>
-            <a:ext cx="1554480" cy="256032"/>
+            <a:ext cx="1005840" cy="256032"/>
           </a:xfrm>
           <a:prstGeom prst="roundRect">
             <a:avLst>
@@ -2671,7 +2696,7 @@
             </a:avLst>
           </a:prstGeom>
           <a:solidFill>
-            <a:srgbClr val="10B981"/>
+            <a:srgbClr val="0D7C5F"/>
           </a:solidFill>
           <a:ln/>
         </p:spPr>
@@ -2685,7 +2710,7 @@
         <p:spPr>
           <a:xfrm>
             <a:off x="4937760" y="1097280"/>
-            <a:ext cx="1554480" cy="256032"/>
+            <a:ext cx="1005840" cy="256032"/>
           </a:xfrm>
           <a:prstGeom prst="rect">
             <a:avLst/>
@@ -2701,7 +2726,7 @@
               <a:buNone/>
             </a:pPr>
             <a:r>
-              <a:rPr lang="en-US" sz="650" b="1" dirty="0">
+              <a:rPr lang="en-US" sz="750" b="1" dirty="0">
                 <a:solidFill>
                   <a:srgbClr val="FFFFFF"/>
                 </a:solidFill>
@@ -2709,9 +2734,9 @@
                 <a:ea typeface="Calibri" pitchFamily="34" charset="-122"/>
                 <a:cs typeface="Calibri" pitchFamily="34" charset="-120"/>
               </a:rPr>
-              <a:t>OPTION 2 — RECOMMENDED</a:t>
-            </a:r>
-            <a:endParaRPr lang="en-US" sz="650" dirty="0"/>
+              <a:t>OPTION 2</a:t>
+            </a:r>
+            <a:endParaRPr lang="en-US" sz="750" dirty="0"/>
           </a:p>
         </p:txBody>
       </p:sp>
@@ -2851,7 +2876,7 @@
             <a:avLst/>
           </a:prstGeom>
           <a:solidFill>
-            <a:srgbClr val="10B981"/>
+            <a:srgbClr val="0D7C5F"/>
           </a:solidFill>
           <a:ln/>
         </p:spPr>
@@ -2910,7 +2935,7 @@
             <a:avLst/>
           </a:prstGeom>
           <a:solidFill>
-            <a:srgbClr val="10B981"/>
+            <a:srgbClr val="0D7C5F"/>
           </a:solidFill>
           <a:ln/>
         </p:spPr>
@@ -2969,7 +2994,7 @@
             <a:avLst/>
           </a:prstGeom>
           <a:solidFill>
-            <a:srgbClr val="10B981"/>
+            <a:srgbClr val="0D7C5F"/>
           </a:solidFill>
           <a:ln/>
         </p:spPr>
@@ -3028,7 +3053,7 @@
             <a:avLst/>
           </a:prstGeom>
           <a:solidFill>
-            <a:srgbClr val="10B981"/>
+            <a:srgbClr val="0D7C5F"/>
           </a:solidFill>
           <a:ln/>
         </p:spPr>
@@ -3087,7 +3112,7 @@
             <a:avLst/>
           </a:prstGeom>
           <a:solidFill>
-            <a:srgbClr val="10B981"/>
+            <a:srgbClr val="0D7C5F"/>
           </a:solidFill>
           <a:ln/>
         </p:spPr>
@@ -3180,7 +3205,7 @@
             <a:r>
               <a:rPr lang="en-US" sz="750" b="1" dirty="0">
                 <a:solidFill>
-                  <a:srgbClr val="10B981"/>
+                  <a:srgbClr val="0D7C5F"/>
                 </a:solidFill>
                 <a:latin typeface="Calibri" pitchFamily="34" charset="0"/>
                 <a:ea typeface="Calibri" pitchFamily="34" charset="-122"/>
@@ -3272,13 +3297,13 @@
         <p:spPr>
           <a:xfrm>
             <a:off x="0" y="0"/>
-            <a:ext cx="9144000" cy="1645920"/>
-          </a:xfrm>
-          <a:prstGeom prst="rect">
-            <a:avLst/>
-          </a:prstGeom>
-          <a:solidFill>
-            <a:srgbClr val="0A0E1A"/>
+            <a:ext cx="9144000" cy="1554480"/>
+          </a:xfrm>
+          <a:prstGeom prst="rect">
+            <a:avLst/>
+          </a:prstGeom>
+          <a:solidFill>
+            <a:srgbClr val="2D5A8B"/>
           </a:solidFill>
           <a:ln/>
         </p:spPr>
@@ -3292,7 +3317,7 @@
         <p:spPr>
           <a:xfrm>
             <a:off x="457200" y="320040"/>
-            <a:ext cx="1463040" cy="237744"/>
+            <a:ext cx="1005840" cy="237744"/>
           </a:xfrm>
           <a:prstGeom prst="roundRect">
             <a:avLst>
@@ -3300,7 +3325,7 @@
             </a:avLst>
           </a:prstGeom>
           <a:solidFill>
-            <a:srgbClr val="10B981"/>
+            <a:srgbClr val="FFFFFF"/>
           </a:solidFill>
           <a:ln/>
         </p:spPr>
@@ -3314,7 +3339,7 @@
         <p:spPr>
           <a:xfrm>
             <a:off x="457200" y="320040"/>
-            <a:ext cx="1463040" cy="237744"/>
+            <a:ext cx="1005840" cy="237744"/>
           </a:xfrm>
           <a:prstGeom prst="rect">
             <a:avLst/>
@@ -3330,17 +3355,17 @@
               <a:buNone/>
             </a:pPr>
             <a:r>
-              <a:rPr lang="en-US" sz="700" b="1" dirty="0">
-                <a:solidFill>
-                  <a:srgbClr val="FFFFFF"/>
-                </a:solidFill>
-                <a:latin typeface="Calibri" pitchFamily="34" charset="0"/>
-                <a:ea typeface="Calibri" pitchFamily="34" charset="-122"/>
-                <a:cs typeface="Calibri" pitchFamily="34" charset="-120"/>
-              </a:rPr>
-              <a:t>RECOMMENDED</a:t>
-            </a:r>
-            <a:endParaRPr lang="en-US" sz="700" dirty="0"/>
+              <a:rPr lang="en-US" sz="750" b="1" dirty="0">
+                <a:solidFill>
+                  <a:srgbClr val="2D5A8B"/>
+                </a:solidFill>
+                <a:latin typeface="Calibri" pitchFamily="34" charset="0"/>
+                <a:ea typeface="Calibri" pitchFamily="34" charset="-122"/>
+                <a:cs typeface="Calibri" pitchFamily="34" charset="-120"/>
+              </a:rPr>
+              <a:t>OPTION 1</a:t>
+            </a:r>
+            <a:endParaRPr lang="en-US" sz="750" dirty="0"/>
           </a:p>
         </p:txBody>
       </p:sp>
@@ -3377,7 +3402,7 @@
                 <a:ea typeface="Cambria" pitchFamily="34" charset="-122"/>
                 <a:cs typeface="Cambria" pitchFamily="34" charset="-120"/>
               </a:rPr>
-              <a:t>Goa Coastal Resorts &amp; Recreation Pvt. Ltd.</a:t>
+              <a:t>CP Goa — Entertainment &amp; Nightlife Website</a:t>
             </a:r>
             <a:endParaRPr lang="en-US" sz="2400" dirty="0"/>
           </a:p>
@@ -3391,7 +3416,7 @@
         </p:nvSpPr>
         <p:spPr>
           <a:xfrm>
-            <a:off x="457200" y="1188720"/>
+            <a:off x="457200" y="1143000"/>
             <a:ext cx="8229600" cy="274320"/>
           </a:xfrm>
           <a:prstGeom prst="rect">
@@ -3410,13 +3435,13 @@
             <a:r>
               <a:rPr lang="en-US" sz="1100" dirty="0">
                 <a:solidFill>
-                  <a:srgbClr val="9CA3AF"/>
-                </a:solidFill>
-                <a:latin typeface="Calibri" pitchFamily="34" charset="0"/>
-                <a:ea typeface="Calibri" pitchFamily="34" charset="-122"/>
-                <a:cs typeface="Calibri" pitchFamily="34" charset="-120"/>
-              </a:rPr>
-              <a:t>Corporate Business Website — Representing the Company’s Broader Identity</a:t>
+                  <a:srgbClr val="D1FAE5"/>
+                </a:solidFill>
+                <a:latin typeface="Calibri" pitchFamily="34" charset="0"/>
+                <a:ea typeface="Calibri" pitchFamily="34" charset="-122"/>
+                <a:cs typeface="Calibri" pitchFamily="34" charset="-120"/>
+              </a:rPr>
+              <a:t>A dedicated sub-domain website positioned around CP Goa as an entertainment brand</a:t>
             </a:r>
             <a:endParaRPr lang="en-US" sz="1100" dirty="0"/>
           </a:p>
@@ -3430,8 +3455,8 @@
         </p:nvSpPr>
         <p:spPr>
           <a:xfrm>
-            <a:off x="457200" y="1920240"/>
-            <a:ext cx="8229600" cy="594360"/>
+            <a:off x="457200" y="1828800"/>
+            <a:ext cx="8229600" cy="548640"/>
           </a:xfrm>
           <a:prstGeom prst="rect">
             <a:avLst/>
@@ -3458,7 +3483,7 @@
                 <a:ea typeface="Calibri" pitchFamily="34" charset="-122"/>
                 <a:cs typeface="Calibri" pitchFamily="34" charset="-120"/>
               </a:rPr>
-              <a:t>Develop a new 5-page website under the domain of Goa Coastal Resorts &amp; Recreation Pvt. Ltd., the company associated with Casino Pride. Instead of positioning the website around casino/gaming, it presents the company’s broader business identity and legitimate activities.</a:t>
+              <a:t>Create a dedicated consumer-facing entertainment presence while keeping the existing cpofficial.in website separate. The website will focus on the entertainment, nightlife, and lifestyle aspects of the brand.</a:t>
             </a:r>
             <a:endParaRPr lang="en-US" sz="1100" dirty="0"/>
           </a:p>
@@ -3472,16 +3497,16 @@
         </p:nvSpPr>
         <p:spPr>
           <a:xfrm>
-            <a:off x="457200" y="2697480"/>
-            <a:ext cx="1600200" cy="347472"/>
+            <a:off x="457200" y="2560320"/>
+            <a:ext cx="1280160" cy="320040"/>
           </a:xfrm>
           <a:prstGeom prst="roundRect">
             <a:avLst>
-              <a:gd name="adj" fmla="val 50000"/>
+              <a:gd name="adj" fmla="val 48571"/>
             </a:avLst>
           </a:prstGeom>
           <a:solidFill>
-            <a:srgbClr val="0A0E1A"/>
+            <a:srgbClr val="2D5A8B"/>
           </a:solidFill>
           <a:ln/>
         </p:spPr>
@@ -3494,8 +3519,8 @@
         </p:nvSpPr>
         <p:spPr>
           <a:xfrm>
-            <a:off x="457200" y="2697480"/>
-            <a:ext cx="1600200" cy="347472"/>
+            <a:off x="457200" y="2560320"/>
+            <a:ext cx="1280160" cy="320040"/>
           </a:xfrm>
           <a:prstGeom prst="rect">
             <a:avLst/>
@@ -3511,7 +3536,7 @@
               <a:buNone/>
             </a:pPr>
             <a:r>
-              <a:rPr lang="en-US" sz="950" b="1" dirty="0">
+              <a:rPr lang="en-US" sz="900" b="1" dirty="0">
                 <a:solidFill>
                   <a:srgbClr val="FFFFFF"/>
                 </a:solidFill>
@@ -3519,9 +3544,9 @@
                 <a:ea typeface="Calibri" pitchFamily="34" charset="-122"/>
                 <a:cs typeface="Calibri" pitchFamily="34" charset="-120"/>
               </a:rPr>
-              <a:t>Hospitality</a:t>
-            </a:r>
-            <a:endParaRPr lang="en-US" sz="950" dirty="0"/>
+              <a:t>Entertainment</a:t>
+            </a:r>
+            <a:endParaRPr lang="en-US" sz="900" dirty="0"/>
           </a:p>
         </p:txBody>
       </p:sp>
@@ -3533,16 +3558,16 @@
         </p:nvSpPr>
         <p:spPr>
           <a:xfrm>
-            <a:off x="2194560" y="2697480"/>
-            <a:ext cx="1600200" cy="347472"/>
+            <a:off x="1874520" y="2560320"/>
+            <a:ext cx="1280160" cy="320040"/>
           </a:xfrm>
           <a:prstGeom prst="roundRect">
             <a:avLst>
-              <a:gd name="adj" fmla="val 50000"/>
+              <a:gd name="adj" fmla="val 48571"/>
             </a:avLst>
           </a:prstGeom>
           <a:solidFill>
-            <a:srgbClr val="0A0E1A"/>
+            <a:srgbClr val="2D5A8B"/>
           </a:solidFill>
           <a:ln/>
         </p:spPr>
@@ -3555,8 +3580,8 @@
         </p:nvSpPr>
         <p:spPr>
           <a:xfrm>
-            <a:off x="2194560" y="2697480"/>
-            <a:ext cx="1600200" cy="347472"/>
+            <a:off x="1874520" y="2560320"/>
+            <a:ext cx="1280160" cy="320040"/>
           </a:xfrm>
           <a:prstGeom prst="rect">
             <a:avLst/>
@@ -3572,7 +3597,7 @@
               <a:buNone/>
             </a:pPr>
             <a:r>
-              <a:rPr lang="en-US" sz="950" b="1" dirty="0">
+              <a:rPr lang="en-US" sz="900" b="1" dirty="0">
                 <a:solidFill>
                   <a:srgbClr val="FFFFFF"/>
                 </a:solidFill>
@@ -3580,9 +3605,9 @@
                 <a:ea typeface="Calibri" pitchFamily="34" charset="-122"/>
                 <a:cs typeface="Calibri" pitchFamily="34" charset="-120"/>
               </a:rPr>
-              <a:t>Entertainment</a:t>
-            </a:r>
-            <a:endParaRPr lang="en-US" sz="950" dirty="0"/>
+              <a:t>Nightlife</a:t>
+            </a:r>
+            <a:endParaRPr lang="en-US" sz="900" dirty="0"/>
           </a:p>
         </p:txBody>
       </p:sp>
@@ -3594,16 +3619,16 @@
         </p:nvSpPr>
         <p:spPr>
           <a:xfrm>
-            <a:off x="3931920" y="2697480"/>
-            <a:ext cx="1600200" cy="347472"/>
+            <a:off x="3291840" y="2560320"/>
+            <a:ext cx="1280160" cy="320040"/>
           </a:xfrm>
           <a:prstGeom prst="roundRect">
             <a:avLst>
-              <a:gd name="adj" fmla="val 50000"/>
+              <a:gd name="adj" fmla="val 48571"/>
             </a:avLst>
           </a:prstGeom>
           <a:solidFill>
-            <a:srgbClr val="0A0E1A"/>
+            <a:srgbClr val="2D5A8B"/>
           </a:solidFill>
           <a:ln/>
         </p:spPr>
@@ -3616,8 +3641,8 @@
         </p:nvSpPr>
         <p:spPr>
           <a:xfrm>
-            <a:off x="3931920" y="2697480"/>
-            <a:ext cx="1600200" cy="347472"/>
+            <a:off x="3291840" y="2560320"/>
+            <a:ext cx="1280160" cy="320040"/>
           </a:xfrm>
           <a:prstGeom prst="rect">
             <a:avLst/>
@@ -3633,7 +3658,7 @@
               <a:buNone/>
             </a:pPr>
             <a:r>
-              <a:rPr lang="en-US" sz="950" b="1" dirty="0">
+              <a:rPr lang="en-US" sz="900" b="1" dirty="0">
                 <a:solidFill>
                   <a:srgbClr val="FFFFFF"/>
                 </a:solidFill>
@@ -3641,9 +3666,9 @@
                 <a:ea typeface="Calibri" pitchFamily="34" charset="-122"/>
                 <a:cs typeface="Calibri" pitchFamily="34" charset="-120"/>
               </a:rPr>
-              <a:t>Recreation</a:t>
-            </a:r>
-            <a:endParaRPr lang="en-US" sz="950" dirty="0"/>
+              <a:t>Live Events</a:t>
+            </a:r>
+            <a:endParaRPr lang="en-US" sz="900" dirty="0"/>
           </a:p>
         </p:txBody>
       </p:sp>
@@ -3655,16 +3680,16 @@
         </p:nvSpPr>
         <p:spPr>
           <a:xfrm>
-            <a:off x="5669280" y="2697480"/>
-            <a:ext cx="1600200" cy="347472"/>
+            <a:off x="4709160" y="2560320"/>
+            <a:ext cx="1280160" cy="320040"/>
           </a:xfrm>
           <a:prstGeom prst="roundRect">
             <a:avLst>
-              <a:gd name="adj" fmla="val 50000"/>
+              <a:gd name="adj" fmla="val 48571"/>
             </a:avLst>
           </a:prstGeom>
           <a:solidFill>
-            <a:srgbClr val="0A0E1A"/>
+            <a:srgbClr val="2D5A8B"/>
           </a:solidFill>
           <a:ln/>
         </p:spPr>
@@ -3677,8 +3702,8 @@
         </p:nvSpPr>
         <p:spPr>
           <a:xfrm>
-            <a:off x="5669280" y="2697480"/>
-            <a:ext cx="1600200" cy="347472"/>
+            <a:off x="4709160" y="2560320"/>
+            <a:ext cx="1280160" cy="320040"/>
           </a:xfrm>
           <a:prstGeom prst="rect">
             <a:avLst/>
@@ -3694,7 +3719,7 @@
               <a:buNone/>
             </a:pPr>
             <a:r>
-              <a:rPr lang="en-US" sz="950" b="1" dirty="0">
+              <a:rPr lang="en-US" sz="900" b="1" dirty="0">
                 <a:solidFill>
                   <a:srgbClr val="FFFFFF"/>
                 </a:solidFill>
@@ -3704,7 +3729,7 @@
               </a:rPr>
               <a:t>Dining</a:t>
             </a:r>
-            <a:endParaRPr lang="en-US" sz="950" dirty="0"/>
+            <a:endParaRPr lang="en-US" sz="900" dirty="0"/>
           </a:p>
         </p:txBody>
       </p:sp>
@@ -3716,16 +3741,16 @@
         </p:nvSpPr>
         <p:spPr>
           <a:xfrm>
-            <a:off x="7406640" y="2697480"/>
-            <a:ext cx="1600200" cy="347472"/>
+            <a:off x="6126480" y="2560320"/>
+            <a:ext cx="1280160" cy="320040"/>
           </a:xfrm>
           <a:prstGeom prst="roundRect">
             <a:avLst>
-              <a:gd name="adj" fmla="val 50000"/>
+              <a:gd name="adj" fmla="val 48571"/>
             </a:avLst>
           </a:prstGeom>
           <a:solidFill>
-            <a:srgbClr val="0A0E1A"/>
+            <a:srgbClr val="2D5A8B"/>
           </a:solidFill>
           <a:ln/>
         </p:spPr>
@@ -3738,8 +3763,8 @@
         </p:nvSpPr>
         <p:spPr>
           <a:xfrm>
-            <a:off x="7406640" y="2697480"/>
-            <a:ext cx="1600200" cy="347472"/>
+            <a:off x="6126480" y="2560320"/>
+            <a:ext cx="1280160" cy="320040"/>
           </a:xfrm>
           <a:prstGeom prst="rect">
             <a:avLst/>
@@ -3755,7 +3780,7 @@
               <a:buNone/>
             </a:pPr>
             <a:r>
-              <a:rPr lang="en-US" sz="950" b="1" dirty="0">
+              <a:rPr lang="en-US" sz="900" b="1" dirty="0">
                 <a:solidFill>
                   <a:srgbClr val="FFFFFF"/>
                 </a:solidFill>
@@ -3763,9 +3788,9 @@
                 <a:ea typeface="Calibri" pitchFamily="34" charset="-122"/>
                 <a:cs typeface="Calibri" pitchFamily="34" charset="-120"/>
               </a:rPr>
-              <a:t>Events</a:t>
-            </a:r>
-            <a:endParaRPr lang="en-US" sz="950" dirty="0"/>
+              <a:t>Recreation</a:t>
+            </a:r>
+            <a:endParaRPr lang="en-US" sz="900" dirty="0"/>
           </a:p>
         </p:txBody>
       </p:sp>
@@ -3777,7 +3802,68 @@
         </p:nvSpPr>
         <p:spPr>
           <a:xfrm>
-            <a:off x="457200" y="3246120"/>
+            <a:off x="7543800" y="2560320"/>
+            <a:ext cx="1280160" cy="320040"/>
+          </a:xfrm>
+          <a:prstGeom prst="roundRect">
+            <a:avLst>
+              <a:gd name="adj" fmla="val 48571"/>
+            </a:avLst>
+          </a:prstGeom>
+          <a:solidFill>
+            <a:srgbClr val="2D5A8B"/>
+          </a:solidFill>
+          <a:ln/>
+        </p:spPr>
+      </p:sp>
+      <p:sp>
+        <p:nvSpPr>
+          <p:cNvPr id="19" name="Text 17"/>
+          <p:cNvSpPr/>
+          <p:nvPr/>
+        </p:nvSpPr>
+        <p:spPr>
+          <a:xfrm>
+            <a:off x="7543800" y="2560320"/>
+            <a:ext cx="1280160" cy="320040"/>
+          </a:xfrm>
+          <a:prstGeom prst="rect">
+            <a:avLst/>
+          </a:prstGeom>
+          <a:noFill/>
+          <a:ln/>
+        </p:spPr>
+        <p:txBody>
+          <a:bodyPr wrap="square" lIns="0" tIns="0" rIns="0" bIns="0" rtlCol="0" anchor="ctr"/>
+          <a:lstStyle/>
+          <a:p>
+            <a:pPr algn="ctr" indent="0" marL="0">
+              <a:buNone/>
+            </a:pPr>
+            <a:r>
+              <a:rPr lang="en-US" sz="900" b="1" dirty="0">
+                <a:solidFill>
+                  <a:srgbClr val="FFFFFF"/>
+                </a:solidFill>
+                <a:latin typeface="Calibri" pitchFamily="34" charset="0"/>
+                <a:ea typeface="Calibri" pitchFamily="34" charset="-122"/>
+                <a:cs typeface="Calibri" pitchFamily="34" charset="-120"/>
+              </a:rPr>
+              <a:t>Experiences</a:t>
+            </a:r>
+            <a:endParaRPr lang="en-US" sz="900" dirty="0"/>
+          </a:p>
+        </p:txBody>
+      </p:sp>
+      <p:sp>
+        <p:nvSpPr>
+          <p:cNvPr id="20" name="Shape 18"/>
+          <p:cNvSpPr/>
+          <p:nvPr/>
+        </p:nvSpPr>
+        <p:spPr>
+          <a:xfrm>
+            <a:off x="457200" y="3108960"/>
             <a:ext cx="8229600" cy="502920"/>
           </a:xfrm>
           <a:prstGeom prst="roundRect">
@@ -3793,13 +3879,13 @@
       </p:sp>
       <p:sp>
         <p:nvSpPr>
-          <p:cNvPr id="19" name="Text 17"/>
-          <p:cNvSpPr/>
-          <p:nvPr/>
-        </p:nvSpPr>
-        <p:spPr>
-          <a:xfrm>
-            <a:off x="640080" y="3246120"/>
+          <p:cNvPr id="21" name="Text 19"/>
+          <p:cNvSpPr/>
+          <p:nvPr/>
+        </p:nvSpPr>
+        <p:spPr>
+          <a:xfrm>
+            <a:off x="640080" y="3108960"/>
             <a:ext cx="7863840" cy="502920"/>
           </a:xfrm>
           <a:prstGeom prst="rect">
@@ -3824,7 +3910,7 @@
                 <a:ea typeface="Calibri" pitchFamily="34" charset="-122"/>
                 <a:cs typeface="Calibri" pitchFamily="34" charset="-120"/>
               </a:rPr>
-              <a:t>PROPOSED PAGES:   Home   •   About the Company   •   Our Businesses &amp; Experiences   •   Brands / Business Interests   •   Contact</a:t>
+              <a:t>PROPOSED 5 PAGES:   Home   •   About CP Goa   •   Entertainment &amp; Nightlife   •   Experiences &amp; Events   •   Contact</a:t>
             </a:r>
             <a:endParaRPr lang="en-US" sz="1000" dirty="0"/>
           </a:p>
@@ -3832,14 +3918,14 @@
       </p:sp>
       <p:sp>
         <p:nvSpPr>
-          <p:cNvPr id="20" name="Text 18"/>
-          <p:cNvSpPr/>
-          <p:nvPr/>
-        </p:nvSpPr>
-        <p:spPr>
-          <a:xfrm>
-            <a:off x="457200" y="3886200"/>
-            <a:ext cx="8229600" cy="274320"/>
+          <p:cNvPr id="22" name="Text 20"/>
+          <p:cNvSpPr/>
+          <p:nvPr/>
+        </p:nvSpPr>
+        <p:spPr>
+          <a:xfrm>
+            <a:off x="457200" y="3794760"/>
+            <a:ext cx="3931920" cy="274320"/>
           </a:xfrm>
           <a:prstGeom prst="rect">
             <a:avLst/>
@@ -3855,15 +3941,54 @@
               <a:buNone/>
             </a:pPr>
             <a:r>
+              <a:rPr lang="en-US" sz="1100" b="1" dirty="0">
+                <a:solidFill>
+                  <a:srgbClr val="2D5A8B"/>
+                </a:solidFill>
+                <a:latin typeface="Calibri" pitchFamily="34" charset="0"/>
+                <a:ea typeface="Calibri" pitchFamily="34" charset="-122"/>
+                <a:cs typeface="Calibri" pitchFamily="34" charset="-120"/>
+              </a:rPr>
+              <a:t>Website Direction</a:t>
+            </a:r>
+            <a:endParaRPr lang="en-US" sz="1100" dirty="0"/>
+          </a:p>
+        </p:txBody>
+      </p:sp>
+      <p:sp>
+        <p:nvSpPr>
+          <p:cNvPr id="23" name="Text 21"/>
+          <p:cNvSpPr/>
+          <p:nvPr/>
+        </p:nvSpPr>
+        <p:spPr>
+          <a:xfrm>
+            <a:off x="457200" y="4023360"/>
+            <a:ext cx="3931920" cy="274320"/>
+          </a:xfrm>
+          <a:prstGeom prst="rect">
+            <a:avLst/>
+          </a:prstGeom>
+          <a:noFill/>
+          <a:ln/>
+        </p:spPr>
+        <p:txBody>
+          <a:bodyPr wrap="square" lIns="0" tIns="0" rIns="0" bIns="0" rtlCol="0" anchor="ctr"/>
+          <a:lstStyle/>
+          <a:p>
+            <a:pPr algn="l" indent="0" marL="0">
+              <a:buNone/>
+            </a:pPr>
+            <a:r>
               <a:rPr lang="en-US" sz="1050" i="1" dirty="0">
                 <a:solidFill>
-                  <a:srgbClr val="4B5563"/>
-                </a:solidFill>
-                <a:latin typeface="Calibri" pitchFamily="34" charset="0"/>
-                <a:ea typeface="Calibri" pitchFamily="34" charset="-122"/>
-                <a:cs typeface="Calibri" pitchFamily="34" charset="-120"/>
-              </a:rPr>
-              <a:t>Casino Pride can be presented accurately as one of the company’s brands/business interests where appropriate.</a:t>
+                  <a:srgbClr val="374151"/>
+                </a:solidFill>
+                <a:latin typeface="Calibri" pitchFamily="34" charset="0"/>
+                <a:ea typeface="Calibri" pitchFamily="34" charset="-122"/>
+                <a:cs typeface="Calibri" pitchFamily="34" charset="-120"/>
+              </a:rPr>
+              <a:t>CP Goa — Entertainment • Nightlife • Experiences</a:t>
             </a:r>
             <a:endParaRPr lang="en-US" sz="1050" dirty="0"/>
           </a:p>
@@ -3871,100 +3996,14 @@
       </p:sp>
       <p:sp>
         <p:nvSpPr>
-          <p:cNvPr id="21" name="Shape 19"/>
-          <p:cNvSpPr/>
-          <p:nvPr/>
-        </p:nvSpPr>
-        <p:spPr>
-          <a:xfrm>
-            <a:off x="457200" y="4297680"/>
-            <a:ext cx="8229600" cy="685800"/>
-          </a:xfrm>
-          <a:prstGeom prst="roundRect">
-            <a:avLst>
-              <a:gd name="adj" fmla="val 10667"/>
-            </a:avLst>
-          </a:prstGeom>
-          <a:solidFill>
-            <a:srgbClr val="ECFDF5"/>
-          </a:solidFill>
-          <a:ln w="9525">
-            <a:solidFill>
-              <a:srgbClr val="10B981"/>
-            </a:solidFill>
-            <a:prstDash val="solid"/>
-          </a:ln>
-        </p:spPr>
-      </p:sp>
-      <p:sp>
-        <p:nvSpPr>
-          <p:cNvPr id="22" name="Shape 20"/>
-          <p:cNvSpPr/>
-          <p:nvPr/>
-        </p:nvSpPr>
-        <p:spPr>
-          <a:xfrm>
-            <a:off x="685800" y="4462272"/>
-            <a:ext cx="320040" cy="320040"/>
-          </a:xfrm>
-          <a:prstGeom prst="ellipse">
-            <a:avLst/>
-          </a:prstGeom>
-          <a:solidFill>
-            <a:srgbClr val="10B981"/>
-          </a:solidFill>
-          <a:ln/>
-        </p:spPr>
-      </p:sp>
-      <p:sp>
-        <p:nvSpPr>
-          <p:cNvPr id="23" name="Text 21"/>
-          <p:cNvSpPr/>
-          <p:nvPr/>
-        </p:nvSpPr>
-        <p:spPr>
-          <a:xfrm>
-            <a:off x="685800" y="4462272"/>
-            <a:ext cx="320040" cy="320040"/>
-          </a:xfrm>
-          <a:prstGeom prst="rect">
-            <a:avLst/>
-          </a:prstGeom>
-          <a:noFill/>
-          <a:ln/>
-        </p:spPr>
-        <p:txBody>
-          <a:bodyPr wrap="square" lIns="0" tIns="0" rIns="0" bIns="0" rtlCol="0" anchor="ctr"/>
-          <a:lstStyle/>
-          <a:p>
-            <a:pPr algn="ctr" indent="0" marL="0">
-              <a:buNone/>
-            </a:pPr>
-            <a:r>
-              <a:rPr lang="en-US" sz="1400" b="1" dirty="0">
-                <a:solidFill>
-                  <a:srgbClr val="FFFFFF"/>
-                </a:solidFill>
-                <a:latin typeface="Calibri" pitchFamily="34" charset="0"/>
-                <a:ea typeface="Calibri" pitchFamily="34" charset="-122"/>
-                <a:cs typeface="Calibri" pitchFamily="34" charset="-120"/>
-              </a:rPr>
-              <a:t>✓</a:t>
-            </a:r>
-            <a:endParaRPr lang="en-US" sz="1400" dirty="0"/>
-          </a:p>
-        </p:txBody>
-      </p:sp>
-      <p:sp>
-        <p:nvSpPr>
           <p:cNvPr id="24" name="Text 22"/>
           <p:cNvSpPr/>
           <p:nvPr/>
         </p:nvSpPr>
         <p:spPr>
           <a:xfrm>
-            <a:off x="1143000" y="4370832"/>
-            <a:ext cx="7315200" cy="182880"/>
+            <a:off x="4754880" y="3794760"/>
+            <a:ext cx="3931920" cy="274320"/>
           </a:xfrm>
           <a:prstGeom prst="rect">
             <a:avLst/>
@@ -3980,17 +4019,17 @@
               <a:buNone/>
             </a:pPr>
             <a:r>
-              <a:rPr lang="en-US" sz="800" b="1" spc="100" kern="0" dirty="0">
-                <a:solidFill>
-                  <a:srgbClr val="10B981"/>
-                </a:solidFill>
-                <a:latin typeface="Calibri" pitchFamily="34" charset="0"/>
-                <a:ea typeface="Calibri" pitchFamily="34" charset="-122"/>
-                <a:cs typeface="Calibri" pitchFamily="34" charset="-120"/>
-              </a:rPr>
-              <a:t>KEY ADVANTAGE</a:t>
-            </a:r>
-            <a:endParaRPr lang="en-US" sz="800" dirty="0"/>
+              <a:rPr lang="en-US" sz="1100" b="1" dirty="0">
+                <a:solidFill>
+                  <a:srgbClr val="2D5A8B"/>
+                </a:solidFill>
+                <a:latin typeface="Calibri" pitchFamily="34" charset="0"/>
+                <a:ea typeface="Calibri" pitchFamily="34" charset="-122"/>
+                <a:cs typeface="Calibri" pitchFamily="34" charset="-120"/>
+              </a:rPr>
+              <a:t>Key Benefit</a:t>
+            </a:r>
+            <a:endParaRPr lang="en-US" sz="1100" dirty="0"/>
           </a:p>
         </p:txBody>
       </p:sp>
@@ -4002,8 +4041,8 @@
         </p:nvSpPr>
         <p:spPr>
           <a:xfrm>
-            <a:off x="1143000" y="4553712"/>
-            <a:ext cx="7315200" cy="365760"/>
+            <a:off x="4754880" y="4023360"/>
+            <a:ext cx="3931920" cy="502920"/>
           </a:xfrm>
           <a:prstGeom prst="rect">
             <a:avLst/>
@@ -4017,20 +4056,20 @@
           <a:p>
             <a:pPr algn="l" indent="0" marL="0">
               <a:lnSpc>
-                <a:spcPct val="130000"/>
+                <a:spcPct val="140000"/>
               </a:lnSpc>
               <a:buNone/>
             </a:pPr>
             <a:r>
               <a:rPr lang="en-US" sz="1000" dirty="0">
                 <a:solidFill>
-                  <a:srgbClr val="064E3B"/>
-                </a:solidFill>
-                <a:latin typeface="Calibri" pitchFamily="34" charset="0"/>
-                <a:ea typeface="Calibri" pitchFamily="34" charset="-122"/>
-                <a:cs typeface="Calibri" pitchFamily="34" charset="-120"/>
-              </a:rPr>
-              <a:t>Creates a stronger corporate digital identity that accommodates existing and future business activities, rather than a website solely around one entertainment brand.</a:t>
+                  <a:srgbClr val="374151"/>
+                </a:solidFill>
+                <a:latin typeface="Calibri" pitchFamily="34" charset="0"/>
+                <a:ea typeface="Calibri" pitchFamily="34" charset="-122"/>
+                <a:cs typeface="Calibri" pitchFamily="34" charset="-120"/>
+              </a:rPr>
+              <a:t>Provides a dedicated consumer-facing entertainment presence while keeping the existing cpofficial.in website completely separate.</a:t>
             </a:r>
             <a:endParaRPr lang="en-US" sz="1000" dirty="0"/>
           </a:p>
@@ -4050,7 +4089,7 @@
     <p:bg>
       <p:bgPr>
         <a:solidFill>
-          <a:srgbClr val="0A0E1A"/>
+          <a:srgbClr val="FFFFFF"/>
         </a:solidFill>
       </p:bgPr>
     </p:bg>
@@ -4076,14 +4115,14 @@
         </p:nvSpPr>
         <p:spPr>
           <a:xfrm>
-            <a:off x="6400800" y="-1828800"/>
-            <a:ext cx="5486400" cy="5486400"/>
-          </a:xfrm>
-          <a:prstGeom prst="ellipse">
-            <a:avLst/>
-          </a:prstGeom>
-          <a:solidFill>
-            <a:srgbClr val="141B2D"/>
+            <a:off x="0" y="0"/>
+            <a:ext cx="9144000" cy="1554480"/>
+          </a:xfrm>
+          <a:prstGeom prst="rect">
+            <a:avLst/>
+          </a:prstGeom>
+          <a:solidFill>
+            <a:srgbClr val="0D7C5F"/>
           </a:solidFill>
           <a:ln/>
         </p:spPr>
@@ -4096,8 +4135,8 @@
         </p:nvSpPr>
         <p:spPr>
           <a:xfrm>
-            <a:off x="457200" y="365760"/>
-            <a:ext cx="2011680" cy="256032"/>
+            <a:off x="457200" y="320040"/>
+            <a:ext cx="1005840" cy="237744"/>
           </a:xfrm>
           <a:prstGeom prst="roundRect">
             <a:avLst>
@@ -4105,7 +4144,7 @@
             </a:avLst>
           </a:prstGeom>
           <a:solidFill>
-            <a:srgbClr val="D4A853"/>
+            <a:srgbClr val="FFFFFF"/>
           </a:solidFill>
           <a:ln/>
         </p:spPr>
@@ -4118,8 +4157,8 @@
         </p:nvSpPr>
         <p:spPr>
           <a:xfrm>
-            <a:off x="457200" y="365760"/>
-            <a:ext cx="2011680" cy="256032"/>
+            <a:off x="457200" y="320040"/>
+            <a:ext cx="1005840" cy="237744"/>
           </a:xfrm>
           <a:prstGeom prst="rect">
             <a:avLst/>
@@ -4135,15 +4174,15 @@
               <a:buNone/>
             </a:pPr>
             <a:r>
-              <a:rPr lang="en-US" sz="750" b="1" spc="100" kern="0" dirty="0">
-                <a:solidFill>
-                  <a:srgbClr val="0A0E1A"/>
-                </a:solidFill>
-                <a:latin typeface="Calibri" pitchFamily="34" charset="0"/>
-                <a:ea typeface="Calibri" pitchFamily="34" charset="-122"/>
-                <a:cs typeface="Calibri" pitchFamily="34" charset="-120"/>
-              </a:rPr>
-              <a:t>OUR RECOMMENDATION</a:t>
+              <a:rPr lang="en-US" sz="750" b="1" dirty="0">
+                <a:solidFill>
+                  <a:srgbClr val="0D7C5F"/>
+                </a:solidFill>
+                <a:latin typeface="Calibri" pitchFamily="34" charset="0"/>
+                <a:ea typeface="Calibri" pitchFamily="34" charset="-122"/>
+                <a:cs typeface="Calibri" pitchFamily="34" charset="-120"/>
+              </a:rPr>
+              <a:t>OPTION 2</a:t>
             </a:r>
             <a:endParaRPr lang="en-US" sz="750" dirty="0"/>
           </a:p>
@@ -4157,8 +4196,8 @@
         </p:nvSpPr>
         <p:spPr>
           <a:xfrm>
-            <a:off x="457200" y="822960"/>
-            <a:ext cx="8229600" cy="502920"/>
+            <a:off x="457200" y="685800"/>
+            <a:ext cx="8229600" cy="457200"/>
           </a:xfrm>
           <a:prstGeom prst="rect">
             <a:avLst/>
@@ -4174,7 +4213,7 @@
               <a:buNone/>
             </a:pPr>
             <a:r>
-              <a:rPr lang="en-US" sz="2600" b="1" dirty="0">
+              <a:rPr lang="en-US" sz="2400" b="1" dirty="0">
                 <a:solidFill>
                   <a:srgbClr val="FFFFFF"/>
                 </a:solidFill>
@@ -4182,9 +4221,9 @@
                 <a:ea typeface="Cambria" pitchFamily="34" charset="-122"/>
                 <a:cs typeface="Cambria" pitchFamily="34" charset="-120"/>
               </a:rPr>
-              <a:t>Option 2 — Corporate Website</a:t>
-            </a:r>
-            <a:endParaRPr lang="en-US" sz="2600" dirty="0"/>
+              <a:t>Goa Coastal Resorts &amp; Recreation Pvt. Ltd.</a:t>
+            </a:r>
+            <a:endParaRPr lang="en-US" sz="2400" dirty="0"/>
           </a:p>
         </p:txBody>
       </p:sp>
@@ -4196,7 +4235,7 @@
         </p:nvSpPr>
         <p:spPr>
           <a:xfrm>
-            <a:off x="457200" y="1325880"/>
+            <a:off x="457200" y="1143000"/>
             <a:ext cx="8229600" cy="274320"/>
           </a:xfrm>
           <a:prstGeom prst="rect">
@@ -4213,41 +4252,61 @@
               <a:buNone/>
             </a:pPr>
             <a:r>
-              <a:rPr lang="en-US" sz="1200" i="1" dirty="0">
-                <a:solidFill>
-                  <a:srgbClr val="D4A853"/>
-                </a:solidFill>
-                <a:latin typeface="Calibri" pitchFamily="34" charset="0"/>
-                <a:ea typeface="Calibri" pitchFamily="34" charset="-122"/>
-                <a:cs typeface="Calibri" pitchFamily="34" charset="-120"/>
-              </a:rPr>
-              <a:t>Goa Coastal Resorts &amp; Recreation Pvt. Ltd.</a:t>
-            </a:r>
-            <a:endParaRPr lang="en-US" sz="1200" dirty="0"/>
-          </a:p>
-        </p:txBody>
-      </p:sp>
-      <p:sp>
-        <p:nvSpPr>
-          <p:cNvPr id="7" name="Shape 5"/>
+              <a:rPr lang="en-US" sz="1100" dirty="0">
+                <a:solidFill>
+                  <a:srgbClr val="D1FAE5"/>
+                </a:solidFill>
+                <a:latin typeface="Calibri" pitchFamily="34" charset="0"/>
+                <a:ea typeface="Calibri" pitchFamily="34" charset="-122"/>
+                <a:cs typeface="Calibri" pitchFamily="34" charset="-120"/>
+              </a:rPr>
+              <a:t>Corporate Business Website — Broader Business Identity</a:t>
+            </a:r>
+            <a:endParaRPr lang="en-US" sz="1100" dirty="0"/>
+          </a:p>
+        </p:txBody>
+      </p:sp>
+      <p:sp>
+        <p:nvSpPr>
+          <p:cNvPr id="7" name="Text 5"/>
           <p:cNvSpPr/>
           <p:nvPr/>
         </p:nvSpPr>
         <p:spPr>
           <a:xfrm>
             <a:off x="457200" y="1828800"/>
-            <a:ext cx="4023360" cy="1097280"/>
-          </a:xfrm>
-          <a:prstGeom prst="roundRect">
-            <a:avLst>
-              <a:gd name="adj" fmla="val 8333"/>
-            </a:avLst>
-          </a:prstGeom>
-          <a:solidFill>
-            <a:srgbClr val="1C2438"/>
-          </a:solidFill>
-          <a:ln/>
-        </p:spPr>
+            <a:ext cx="8229600" cy="594360"/>
+          </a:xfrm>
+          <a:prstGeom prst="rect">
+            <a:avLst/>
+          </a:prstGeom>
+          <a:noFill/>
+          <a:ln/>
+        </p:spPr>
+        <p:txBody>
+          <a:bodyPr wrap="square" lIns="0" tIns="0" rIns="0" bIns="0" rtlCol="0" anchor="ctr"/>
+          <a:lstStyle/>
+          <a:p>
+            <a:pPr algn="l" indent="0" marL="0">
+              <a:lnSpc>
+                <a:spcPct val="150000"/>
+              </a:lnSpc>
+              <a:buNone/>
+            </a:pPr>
+            <a:r>
+              <a:rPr lang="en-US" sz="1100" dirty="0">
+                <a:solidFill>
+                  <a:srgbClr val="374151"/>
+                </a:solidFill>
+                <a:latin typeface="Calibri" pitchFamily="34" charset="0"/>
+                <a:ea typeface="Calibri" pitchFamily="34" charset="-122"/>
+                <a:cs typeface="Calibri" pitchFamily="34" charset="-120"/>
+              </a:rPr>
+              <a:t>Develop a new 5-page website under the domain of Goa Coastal Resorts &amp; Recreation Pvt. Ltd., the company associated with Casino Pride. Instead of positioning the website around casino/gaming, it presents the company’s broader business identity and legitimate activities.</a:t>
+            </a:r>
+            <a:endParaRPr lang="en-US" sz="1100" dirty="0"/>
+          </a:p>
+        </p:txBody>
       </p:sp>
       <p:sp>
         <p:nvSpPr>
@@ -4257,8 +4316,8 @@
         </p:nvSpPr>
         <p:spPr>
           <a:xfrm>
-            <a:off x="594360" y="2057400"/>
-            <a:ext cx="36576" cy="640080"/>
+            <a:off x="457200" y="2606040"/>
+            <a:ext cx="1600200" cy="347472"/>
           </a:xfrm>
           <a:prstGeom prst="roundRect">
             <a:avLst>
@@ -4266,7 +4325,7 @@
             </a:avLst>
           </a:prstGeom>
           <a:solidFill>
-            <a:srgbClr val="D4A853"/>
+            <a:srgbClr val="0D7C5F"/>
           </a:solidFill>
           <a:ln/>
         </p:spPr>
@@ -4279,8 +4338,313 @@
         </p:nvSpPr>
         <p:spPr>
           <a:xfrm>
-            <a:off x="822960" y="1965960"/>
-            <a:ext cx="3474720" cy="365760"/>
+            <a:off x="457200" y="2606040"/>
+            <a:ext cx="1600200" cy="347472"/>
+          </a:xfrm>
+          <a:prstGeom prst="rect">
+            <a:avLst/>
+          </a:prstGeom>
+          <a:noFill/>
+          <a:ln/>
+        </p:spPr>
+        <p:txBody>
+          <a:bodyPr wrap="square" lIns="0" tIns="0" rIns="0" bIns="0" rtlCol="0" anchor="ctr"/>
+          <a:lstStyle/>
+          <a:p>
+            <a:pPr algn="ctr" indent="0" marL="0">
+              <a:buNone/>
+            </a:pPr>
+            <a:r>
+              <a:rPr lang="en-US" sz="950" b="1" dirty="0">
+                <a:solidFill>
+                  <a:srgbClr val="FFFFFF"/>
+                </a:solidFill>
+                <a:latin typeface="Calibri" pitchFamily="34" charset="0"/>
+                <a:ea typeface="Calibri" pitchFamily="34" charset="-122"/>
+                <a:cs typeface="Calibri" pitchFamily="34" charset="-120"/>
+              </a:rPr>
+              <a:t>Hospitality</a:t>
+            </a:r>
+            <a:endParaRPr lang="en-US" sz="950" dirty="0"/>
+          </a:p>
+        </p:txBody>
+      </p:sp>
+      <p:sp>
+        <p:nvSpPr>
+          <p:cNvPr id="10" name="Shape 8"/>
+          <p:cNvSpPr/>
+          <p:nvPr/>
+        </p:nvSpPr>
+        <p:spPr>
+          <a:xfrm>
+            <a:off x="2194560" y="2606040"/>
+            <a:ext cx="1600200" cy="347472"/>
+          </a:xfrm>
+          <a:prstGeom prst="roundRect">
+            <a:avLst>
+              <a:gd name="adj" fmla="val 50000"/>
+            </a:avLst>
+          </a:prstGeom>
+          <a:solidFill>
+            <a:srgbClr val="0D7C5F"/>
+          </a:solidFill>
+          <a:ln/>
+        </p:spPr>
+      </p:sp>
+      <p:sp>
+        <p:nvSpPr>
+          <p:cNvPr id="11" name="Text 9"/>
+          <p:cNvSpPr/>
+          <p:nvPr/>
+        </p:nvSpPr>
+        <p:spPr>
+          <a:xfrm>
+            <a:off x="2194560" y="2606040"/>
+            <a:ext cx="1600200" cy="347472"/>
+          </a:xfrm>
+          <a:prstGeom prst="rect">
+            <a:avLst/>
+          </a:prstGeom>
+          <a:noFill/>
+          <a:ln/>
+        </p:spPr>
+        <p:txBody>
+          <a:bodyPr wrap="square" lIns="0" tIns="0" rIns="0" bIns="0" rtlCol="0" anchor="ctr"/>
+          <a:lstStyle/>
+          <a:p>
+            <a:pPr algn="ctr" indent="0" marL="0">
+              <a:buNone/>
+            </a:pPr>
+            <a:r>
+              <a:rPr lang="en-US" sz="950" b="1" dirty="0">
+                <a:solidFill>
+                  <a:srgbClr val="FFFFFF"/>
+                </a:solidFill>
+                <a:latin typeface="Calibri" pitchFamily="34" charset="0"/>
+                <a:ea typeface="Calibri" pitchFamily="34" charset="-122"/>
+                <a:cs typeface="Calibri" pitchFamily="34" charset="-120"/>
+              </a:rPr>
+              <a:t>Entertainment</a:t>
+            </a:r>
+            <a:endParaRPr lang="en-US" sz="950" dirty="0"/>
+          </a:p>
+        </p:txBody>
+      </p:sp>
+      <p:sp>
+        <p:nvSpPr>
+          <p:cNvPr id="12" name="Shape 10"/>
+          <p:cNvSpPr/>
+          <p:nvPr/>
+        </p:nvSpPr>
+        <p:spPr>
+          <a:xfrm>
+            <a:off x="3931920" y="2606040"/>
+            <a:ext cx="1600200" cy="347472"/>
+          </a:xfrm>
+          <a:prstGeom prst="roundRect">
+            <a:avLst>
+              <a:gd name="adj" fmla="val 50000"/>
+            </a:avLst>
+          </a:prstGeom>
+          <a:solidFill>
+            <a:srgbClr val="0D7C5F"/>
+          </a:solidFill>
+          <a:ln/>
+        </p:spPr>
+      </p:sp>
+      <p:sp>
+        <p:nvSpPr>
+          <p:cNvPr id="13" name="Text 11"/>
+          <p:cNvSpPr/>
+          <p:nvPr/>
+        </p:nvSpPr>
+        <p:spPr>
+          <a:xfrm>
+            <a:off x="3931920" y="2606040"/>
+            <a:ext cx="1600200" cy="347472"/>
+          </a:xfrm>
+          <a:prstGeom prst="rect">
+            <a:avLst/>
+          </a:prstGeom>
+          <a:noFill/>
+          <a:ln/>
+        </p:spPr>
+        <p:txBody>
+          <a:bodyPr wrap="square" lIns="0" tIns="0" rIns="0" bIns="0" rtlCol="0" anchor="ctr"/>
+          <a:lstStyle/>
+          <a:p>
+            <a:pPr algn="ctr" indent="0" marL="0">
+              <a:buNone/>
+            </a:pPr>
+            <a:r>
+              <a:rPr lang="en-US" sz="950" b="1" dirty="0">
+                <a:solidFill>
+                  <a:srgbClr val="FFFFFF"/>
+                </a:solidFill>
+                <a:latin typeface="Calibri" pitchFamily="34" charset="0"/>
+                <a:ea typeface="Calibri" pitchFamily="34" charset="-122"/>
+                <a:cs typeface="Calibri" pitchFamily="34" charset="-120"/>
+              </a:rPr>
+              <a:t>Recreation</a:t>
+            </a:r>
+            <a:endParaRPr lang="en-US" sz="950" dirty="0"/>
+          </a:p>
+        </p:txBody>
+      </p:sp>
+      <p:sp>
+        <p:nvSpPr>
+          <p:cNvPr id="14" name="Shape 12"/>
+          <p:cNvSpPr/>
+          <p:nvPr/>
+        </p:nvSpPr>
+        <p:spPr>
+          <a:xfrm>
+            <a:off x="5669280" y="2606040"/>
+            <a:ext cx="1600200" cy="347472"/>
+          </a:xfrm>
+          <a:prstGeom prst="roundRect">
+            <a:avLst>
+              <a:gd name="adj" fmla="val 50000"/>
+            </a:avLst>
+          </a:prstGeom>
+          <a:solidFill>
+            <a:srgbClr val="0D7C5F"/>
+          </a:solidFill>
+          <a:ln/>
+        </p:spPr>
+      </p:sp>
+      <p:sp>
+        <p:nvSpPr>
+          <p:cNvPr id="15" name="Text 13"/>
+          <p:cNvSpPr/>
+          <p:nvPr/>
+        </p:nvSpPr>
+        <p:spPr>
+          <a:xfrm>
+            <a:off x="5669280" y="2606040"/>
+            <a:ext cx="1600200" cy="347472"/>
+          </a:xfrm>
+          <a:prstGeom prst="rect">
+            <a:avLst/>
+          </a:prstGeom>
+          <a:noFill/>
+          <a:ln/>
+        </p:spPr>
+        <p:txBody>
+          <a:bodyPr wrap="square" lIns="0" tIns="0" rIns="0" bIns="0" rtlCol="0" anchor="ctr"/>
+          <a:lstStyle/>
+          <a:p>
+            <a:pPr algn="ctr" indent="0" marL="0">
+              <a:buNone/>
+            </a:pPr>
+            <a:r>
+              <a:rPr lang="en-US" sz="950" b="1" dirty="0">
+                <a:solidFill>
+                  <a:srgbClr val="FFFFFF"/>
+                </a:solidFill>
+                <a:latin typeface="Calibri" pitchFamily="34" charset="0"/>
+                <a:ea typeface="Calibri" pitchFamily="34" charset="-122"/>
+                <a:cs typeface="Calibri" pitchFamily="34" charset="-120"/>
+              </a:rPr>
+              <a:t>Dining</a:t>
+            </a:r>
+            <a:endParaRPr lang="en-US" sz="950" dirty="0"/>
+          </a:p>
+        </p:txBody>
+      </p:sp>
+      <p:sp>
+        <p:nvSpPr>
+          <p:cNvPr id="16" name="Shape 14"/>
+          <p:cNvSpPr/>
+          <p:nvPr/>
+        </p:nvSpPr>
+        <p:spPr>
+          <a:xfrm>
+            <a:off x="7406640" y="2606040"/>
+            <a:ext cx="1600200" cy="347472"/>
+          </a:xfrm>
+          <a:prstGeom prst="roundRect">
+            <a:avLst>
+              <a:gd name="adj" fmla="val 50000"/>
+            </a:avLst>
+          </a:prstGeom>
+          <a:solidFill>
+            <a:srgbClr val="0D7C5F"/>
+          </a:solidFill>
+          <a:ln/>
+        </p:spPr>
+      </p:sp>
+      <p:sp>
+        <p:nvSpPr>
+          <p:cNvPr id="17" name="Text 15"/>
+          <p:cNvSpPr/>
+          <p:nvPr/>
+        </p:nvSpPr>
+        <p:spPr>
+          <a:xfrm>
+            <a:off x="7406640" y="2606040"/>
+            <a:ext cx="1600200" cy="347472"/>
+          </a:xfrm>
+          <a:prstGeom prst="rect">
+            <a:avLst/>
+          </a:prstGeom>
+          <a:noFill/>
+          <a:ln/>
+        </p:spPr>
+        <p:txBody>
+          <a:bodyPr wrap="square" lIns="0" tIns="0" rIns="0" bIns="0" rtlCol="0" anchor="ctr"/>
+          <a:lstStyle/>
+          <a:p>
+            <a:pPr algn="ctr" indent="0" marL="0">
+              <a:buNone/>
+            </a:pPr>
+            <a:r>
+              <a:rPr lang="en-US" sz="950" b="1" dirty="0">
+                <a:solidFill>
+                  <a:srgbClr val="FFFFFF"/>
+                </a:solidFill>
+                <a:latin typeface="Calibri" pitchFamily="34" charset="0"/>
+                <a:ea typeface="Calibri" pitchFamily="34" charset="-122"/>
+                <a:cs typeface="Calibri" pitchFamily="34" charset="-120"/>
+              </a:rPr>
+              <a:t>Events</a:t>
+            </a:r>
+            <a:endParaRPr lang="en-US" sz="950" dirty="0"/>
+          </a:p>
+        </p:txBody>
+      </p:sp>
+      <p:sp>
+        <p:nvSpPr>
+          <p:cNvPr id="18" name="Shape 16"/>
+          <p:cNvSpPr/>
+          <p:nvPr/>
+        </p:nvSpPr>
+        <p:spPr>
+          <a:xfrm>
+            <a:off x="457200" y="3154680"/>
+            <a:ext cx="8229600" cy="502920"/>
+          </a:xfrm>
+          <a:prstGeom prst="roundRect">
+            <a:avLst>
+              <a:gd name="adj" fmla="val 14545"/>
+            </a:avLst>
+          </a:prstGeom>
+          <a:solidFill>
+            <a:srgbClr val="ECFDF5"/>
+          </a:solidFill>
+          <a:ln/>
+        </p:spPr>
+      </p:sp>
+      <p:sp>
+        <p:nvSpPr>
+          <p:cNvPr id="19" name="Text 17"/>
+          <p:cNvSpPr/>
+          <p:nvPr/>
+        </p:nvSpPr>
+        <p:spPr>
+          <a:xfrm>
+            <a:off x="640080" y="3154680"/>
+            <a:ext cx="7863840" cy="502920"/>
           </a:xfrm>
           <a:prstGeom prst="rect">
             <a:avLst/>
@@ -4296,30 +4660,135 @@
               <a:buNone/>
             </a:pPr>
             <a:r>
-              <a:rPr lang="en-US" sz="1300" b="1" dirty="0">
-                <a:solidFill>
-                  <a:srgbClr val="FFFFFF"/>
-                </a:solidFill>
-                <a:latin typeface="Cambria" pitchFamily="34" charset="0"/>
-                <a:ea typeface="Cambria" pitchFamily="34" charset="-122"/>
-                <a:cs typeface="Cambria" pitchFamily="34" charset="-120"/>
-              </a:rPr>
-              <a:t>More Credible</a:t>
-            </a:r>
-            <a:endParaRPr lang="en-US" sz="1300" dirty="0"/>
-          </a:p>
-        </p:txBody>
-      </p:sp>
-      <p:sp>
-        <p:nvSpPr>
-          <p:cNvPr id="10" name="Text 8"/>
-          <p:cNvSpPr/>
-          <p:nvPr/>
-        </p:nvSpPr>
-        <p:spPr>
-          <a:xfrm>
-            <a:off x="822960" y="2331720"/>
-            <a:ext cx="3474720" cy="457200"/>
+              <a:rPr lang="en-US" sz="1000" b="1" dirty="0">
+                <a:solidFill>
+                  <a:srgbClr val="065F46"/>
+                </a:solidFill>
+                <a:latin typeface="Calibri" pitchFamily="34" charset="0"/>
+                <a:ea typeface="Calibri" pitchFamily="34" charset="-122"/>
+                <a:cs typeface="Calibri" pitchFamily="34" charset="-120"/>
+              </a:rPr>
+              <a:t>PROPOSED 5 PAGES:   Home   •   About the Company   •   Our Businesses &amp; Experiences   •   Brands / Business Interests   •   Contact</a:t>
+            </a:r>
+            <a:endParaRPr lang="en-US" sz="1000" dirty="0"/>
+          </a:p>
+        </p:txBody>
+      </p:sp>
+      <p:sp>
+        <p:nvSpPr>
+          <p:cNvPr id="20" name="Text 18"/>
+          <p:cNvSpPr/>
+          <p:nvPr/>
+        </p:nvSpPr>
+        <p:spPr>
+          <a:xfrm>
+            <a:off x="457200" y="3794760"/>
+            <a:ext cx="8229600" cy="274320"/>
+          </a:xfrm>
+          <a:prstGeom prst="rect">
+            <a:avLst/>
+          </a:prstGeom>
+          <a:noFill/>
+          <a:ln/>
+        </p:spPr>
+        <p:txBody>
+          <a:bodyPr wrap="square" lIns="0" tIns="0" rIns="0" bIns="0" rtlCol="0" anchor="ctr"/>
+          <a:lstStyle/>
+          <a:p>
+            <a:pPr algn="l" indent="0" marL="0">
+              <a:buNone/>
+            </a:pPr>
+            <a:r>
+              <a:rPr lang="en-US" sz="1050" i="1" dirty="0">
+                <a:solidFill>
+                  <a:srgbClr val="4B5563"/>
+                </a:solidFill>
+                <a:latin typeface="Calibri" pitchFamily="34" charset="0"/>
+                <a:ea typeface="Calibri" pitchFamily="34" charset="-122"/>
+                <a:cs typeface="Calibri" pitchFamily="34" charset="-120"/>
+              </a:rPr>
+              <a:t>Casino Pride can be presented accurately as one of the company’s brands/business interests where appropriate.</a:t>
+            </a:r>
+            <a:endParaRPr lang="en-US" sz="1050" dirty="0"/>
+          </a:p>
+        </p:txBody>
+      </p:sp>
+      <p:sp>
+        <p:nvSpPr>
+          <p:cNvPr id="21" name="Shape 19"/>
+          <p:cNvSpPr/>
+          <p:nvPr/>
+        </p:nvSpPr>
+        <p:spPr>
+          <a:xfrm>
+            <a:off x="457200" y="4206240"/>
+            <a:ext cx="8229600" cy="777240"/>
+          </a:xfrm>
+          <a:prstGeom prst="roundRect">
+            <a:avLst>
+              <a:gd name="adj" fmla="val 9412"/>
+            </a:avLst>
+          </a:prstGeom>
+          <a:solidFill>
+            <a:srgbClr val="ECFDF5"/>
+          </a:solidFill>
+          <a:ln w="9525">
+            <a:solidFill>
+              <a:srgbClr val="34D399"/>
+            </a:solidFill>
+            <a:prstDash val="solid"/>
+          </a:ln>
+        </p:spPr>
+      </p:sp>
+      <p:sp>
+        <p:nvSpPr>
+          <p:cNvPr id="22" name="Text 20"/>
+          <p:cNvSpPr/>
+          <p:nvPr/>
+        </p:nvSpPr>
+        <p:spPr>
+          <a:xfrm>
+            <a:off x="685800" y="4279392"/>
+            <a:ext cx="7772400" cy="182880"/>
+          </a:xfrm>
+          <a:prstGeom prst="rect">
+            <a:avLst/>
+          </a:prstGeom>
+          <a:noFill/>
+          <a:ln/>
+        </p:spPr>
+        <p:txBody>
+          <a:bodyPr wrap="square" lIns="0" tIns="0" rIns="0" bIns="0" rtlCol="0" anchor="ctr"/>
+          <a:lstStyle/>
+          <a:p>
+            <a:pPr algn="l" indent="0" marL="0">
+              <a:buNone/>
+            </a:pPr>
+            <a:r>
+              <a:rPr lang="en-US" sz="800" b="1" spc="100" kern="0" dirty="0">
+                <a:solidFill>
+                  <a:srgbClr val="0D7C5F"/>
+                </a:solidFill>
+                <a:latin typeface="Calibri" pitchFamily="34" charset="0"/>
+                <a:ea typeface="Calibri" pitchFamily="34" charset="-122"/>
+                <a:cs typeface="Calibri" pitchFamily="34" charset="-120"/>
+              </a:rPr>
+              <a:t>KEY ADVANTAGE</a:t>
+            </a:r>
+            <a:endParaRPr lang="en-US" sz="800" dirty="0"/>
+          </a:p>
+        </p:txBody>
+      </p:sp>
+      <p:sp>
+        <p:nvSpPr>
+          <p:cNvPr id="23" name="Text 21"/>
+          <p:cNvSpPr/>
+          <p:nvPr/>
+        </p:nvSpPr>
+        <p:spPr>
+          <a:xfrm>
+            <a:off x="685800" y="4480560"/>
+            <a:ext cx="7772400" cy="411480"/>
           </a:xfrm>
           <a:prstGeom prst="rect">
             <a:avLst/>
@@ -4338,490 +4807,17 @@
               <a:buNone/>
             </a:pPr>
             <a:r>
-              <a:rPr lang="en-US" sz="1000" dirty="0">
-                <a:solidFill>
-                  <a:srgbClr val="9CA3AF"/>
-                </a:solidFill>
-                <a:latin typeface="Calibri" pitchFamily="34" charset="0"/>
-                <a:ea typeface="Calibri" pitchFamily="34" charset="-122"/>
-                <a:cs typeface="Calibri" pitchFamily="34" charset="-120"/>
-              </a:rPr>
-              <a:t>Represents the actual corporate/business entity</a:t>
-            </a:r>
-            <a:endParaRPr lang="en-US" sz="1000" dirty="0"/>
-          </a:p>
-        </p:txBody>
-      </p:sp>
-      <p:sp>
-        <p:nvSpPr>
-          <p:cNvPr id="11" name="Shape 9"/>
-          <p:cNvSpPr/>
-          <p:nvPr/>
-        </p:nvSpPr>
-        <p:spPr>
-          <a:xfrm>
-            <a:off x="4754880" y="1828800"/>
-            <a:ext cx="4023360" cy="1097280"/>
-          </a:xfrm>
-          <a:prstGeom prst="roundRect">
-            <a:avLst>
-              <a:gd name="adj" fmla="val 8333"/>
-            </a:avLst>
-          </a:prstGeom>
-          <a:solidFill>
-            <a:srgbClr val="1C2438"/>
-          </a:solidFill>
-          <a:ln/>
-        </p:spPr>
-      </p:sp>
-      <p:sp>
-        <p:nvSpPr>
-          <p:cNvPr id="12" name="Shape 10"/>
-          <p:cNvSpPr/>
-          <p:nvPr/>
-        </p:nvSpPr>
-        <p:spPr>
-          <a:xfrm>
-            <a:off x="4892040" y="2057400"/>
-            <a:ext cx="36576" cy="640080"/>
-          </a:xfrm>
-          <a:prstGeom prst="roundRect">
-            <a:avLst>
-              <a:gd name="adj" fmla="val 50000"/>
-            </a:avLst>
-          </a:prstGeom>
-          <a:solidFill>
-            <a:srgbClr val="D4A853"/>
-          </a:solidFill>
-          <a:ln/>
-        </p:spPr>
-      </p:sp>
-      <p:sp>
-        <p:nvSpPr>
-          <p:cNvPr id="13" name="Text 11"/>
-          <p:cNvSpPr/>
-          <p:nvPr/>
-        </p:nvSpPr>
-        <p:spPr>
-          <a:xfrm>
-            <a:off x="5120640" y="1965960"/>
-            <a:ext cx="3474720" cy="365760"/>
-          </a:xfrm>
-          <a:prstGeom prst="rect">
-            <a:avLst/>
-          </a:prstGeom>
-          <a:noFill/>
-          <a:ln/>
-        </p:spPr>
-        <p:txBody>
-          <a:bodyPr wrap="square" lIns="0" tIns="0" rIns="0" bIns="0" rtlCol="0" anchor="ctr"/>
-          <a:lstStyle/>
-          <a:p>
-            <a:pPr algn="l" indent="0" marL="0">
-              <a:buNone/>
-            </a:pPr>
-            <a:r>
-              <a:rPr lang="en-US" sz="1300" b="1" dirty="0">
-                <a:solidFill>
-                  <a:srgbClr val="FFFFFF"/>
-                </a:solidFill>
-                <a:latin typeface="Cambria" pitchFamily="34" charset="0"/>
-                <a:ea typeface="Cambria" pitchFamily="34" charset="-122"/>
-                <a:cs typeface="Cambria" pitchFamily="34" charset="-120"/>
-              </a:rPr>
-              <a:t>More Flexible</a:t>
-            </a:r>
-            <a:endParaRPr lang="en-US" sz="1300" dirty="0"/>
-          </a:p>
-        </p:txBody>
-      </p:sp>
-      <p:sp>
-        <p:nvSpPr>
-          <p:cNvPr id="14" name="Text 12"/>
-          <p:cNvSpPr/>
-          <p:nvPr/>
-        </p:nvSpPr>
-        <p:spPr>
-          <a:xfrm>
-            <a:off x="5120640" y="2331720"/>
-            <a:ext cx="3474720" cy="457200"/>
-          </a:xfrm>
-          <a:prstGeom prst="rect">
-            <a:avLst/>
-          </a:prstGeom>
-          <a:noFill/>
-          <a:ln/>
-        </p:spPr>
-        <p:txBody>
-          <a:bodyPr wrap="square" lIns="0" tIns="0" rIns="0" bIns="0" rtlCol="0" anchor="ctr"/>
-          <a:lstStyle/>
-          <a:p>
-            <a:pPr algn="l" indent="0" marL="0">
-              <a:lnSpc>
-                <a:spcPct val="130000"/>
-              </a:lnSpc>
-              <a:buNone/>
-            </a:pPr>
-            <a:r>
-              <a:rPr lang="en-US" sz="1000" dirty="0">
-                <a:solidFill>
-                  <a:srgbClr val="9CA3AF"/>
-                </a:solidFill>
-                <a:latin typeface="Calibri" pitchFamily="34" charset="0"/>
-                <a:ea typeface="Calibri" pitchFamily="34" charset="-122"/>
-                <a:cs typeface="Calibri" pitchFamily="34" charset="-120"/>
-              </a:rPr>
-              <a:t>Showcases hospitality, entertainment, recreation, dining &amp; other activities</a:t>
-            </a:r>
-            <a:endParaRPr lang="en-US" sz="1000" dirty="0"/>
-          </a:p>
-        </p:txBody>
-      </p:sp>
-      <p:sp>
-        <p:nvSpPr>
-          <p:cNvPr id="15" name="Shape 13"/>
-          <p:cNvSpPr/>
-          <p:nvPr/>
-        </p:nvSpPr>
-        <p:spPr>
-          <a:xfrm>
-            <a:off x="457200" y="3108960"/>
-            <a:ext cx="4023360" cy="1097280"/>
-          </a:xfrm>
-          <a:prstGeom prst="roundRect">
-            <a:avLst>
-              <a:gd name="adj" fmla="val 8333"/>
-            </a:avLst>
-          </a:prstGeom>
-          <a:solidFill>
-            <a:srgbClr val="1C2438"/>
-          </a:solidFill>
-          <a:ln/>
-        </p:spPr>
-      </p:sp>
-      <p:sp>
-        <p:nvSpPr>
-          <p:cNvPr id="16" name="Shape 14"/>
-          <p:cNvSpPr/>
-          <p:nvPr/>
-        </p:nvSpPr>
-        <p:spPr>
-          <a:xfrm>
-            <a:off x="594360" y="3337560"/>
-            <a:ext cx="36576" cy="640080"/>
-          </a:xfrm>
-          <a:prstGeom prst="roundRect">
-            <a:avLst>
-              <a:gd name="adj" fmla="val 50000"/>
-            </a:avLst>
-          </a:prstGeom>
-          <a:solidFill>
-            <a:srgbClr val="D4A853"/>
-          </a:solidFill>
-          <a:ln/>
-        </p:spPr>
-      </p:sp>
-      <p:sp>
-        <p:nvSpPr>
-          <p:cNvPr id="17" name="Text 15"/>
-          <p:cNvSpPr/>
-          <p:nvPr/>
-        </p:nvSpPr>
-        <p:spPr>
-          <a:xfrm>
-            <a:off x="822960" y="3246120"/>
-            <a:ext cx="3474720" cy="365760"/>
-          </a:xfrm>
-          <a:prstGeom prst="rect">
-            <a:avLst/>
-          </a:prstGeom>
-          <a:noFill/>
-          <a:ln/>
-        </p:spPr>
-        <p:txBody>
-          <a:bodyPr wrap="square" lIns="0" tIns="0" rIns="0" bIns="0" rtlCol="0" anchor="ctr"/>
-          <a:lstStyle/>
-          <a:p>
-            <a:pPr algn="l" indent="0" marL="0">
-              <a:buNone/>
-            </a:pPr>
-            <a:r>
-              <a:rPr lang="en-US" sz="1300" b="1" dirty="0">
-                <a:solidFill>
-                  <a:srgbClr val="FFFFFF"/>
-                </a:solidFill>
-                <a:latin typeface="Cambria" pitchFamily="34" charset="0"/>
-                <a:ea typeface="Cambria" pitchFamily="34" charset="-122"/>
-                <a:cs typeface="Cambria" pitchFamily="34" charset="-120"/>
-              </a:rPr>
-              <a:t>More Scalable</a:t>
-            </a:r>
-            <a:endParaRPr lang="en-US" sz="1300" dirty="0"/>
-          </a:p>
-        </p:txBody>
-      </p:sp>
-      <p:sp>
-        <p:nvSpPr>
-          <p:cNvPr id="18" name="Text 16"/>
-          <p:cNvSpPr/>
-          <p:nvPr/>
-        </p:nvSpPr>
-        <p:spPr>
-          <a:xfrm>
-            <a:off x="822960" y="3611880"/>
-            <a:ext cx="3474720" cy="457200"/>
-          </a:xfrm>
-          <a:prstGeom prst="rect">
-            <a:avLst/>
-          </a:prstGeom>
-          <a:noFill/>
-          <a:ln/>
-        </p:spPr>
-        <p:txBody>
-          <a:bodyPr wrap="square" lIns="0" tIns="0" rIns="0" bIns="0" rtlCol="0" anchor="ctr"/>
-          <a:lstStyle/>
-          <a:p>
-            <a:pPr algn="l" indent="0" marL="0">
-              <a:lnSpc>
-                <a:spcPct val="130000"/>
-              </a:lnSpc>
-              <a:buNone/>
-            </a:pPr>
-            <a:r>
-              <a:rPr lang="en-US" sz="1000" dirty="0">
-                <a:solidFill>
-                  <a:srgbClr val="9CA3AF"/>
-                </a:solidFill>
-                <a:latin typeface="Calibri" pitchFamily="34" charset="0"/>
-                <a:ea typeface="Calibri" pitchFamily="34" charset="-122"/>
-                <a:cs typeface="Calibri" pitchFamily="34" charset="-120"/>
-              </a:rPr>
-              <a:t>Additional brands, properties or business interests can be added in future</a:t>
-            </a:r>
-            <a:endParaRPr lang="en-US" sz="1000" dirty="0"/>
-          </a:p>
-        </p:txBody>
-      </p:sp>
-      <p:sp>
-        <p:nvSpPr>
-          <p:cNvPr id="19" name="Shape 17"/>
-          <p:cNvSpPr/>
-          <p:nvPr/>
-        </p:nvSpPr>
-        <p:spPr>
-          <a:xfrm>
-            <a:off x="4754880" y="3108960"/>
-            <a:ext cx="4023360" cy="1097280"/>
-          </a:xfrm>
-          <a:prstGeom prst="roundRect">
-            <a:avLst>
-              <a:gd name="adj" fmla="val 8333"/>
-            </a:avLst>
-          </a:prstGeom>
-          <a:solidFill>
-            <a:srgbClr val="1C2438"/>
-          </a:solidFill>
-          <a:ln/>
-        </p:spPr>
-      </p:sp>
-      <p:sp>
-        <p:nvSpPr>
-          <p:cNvPr id="20" name="Shape 18"/>
-          <p:cNvSpPr/>
-          <p:nvPr/>
-        </p:nvSpPr>
-        <p:spPr>
-          <a:xfrm>
-            <a:off x="4892040" y="3337560"/>
-            <a:ext cx="36576" cy="640080"/>
-          </a:xfrm>
-          <a:prstGeom prst="roundRect">
-            <a:avLst>
-              <a:gd name="adj" fmla="val 50000"/>
-            </a:avLst>
-          </a:prstGeom>
-          <a:solidFill>
-            <a:srgbClr val="D4A853"/>
-          </a:solidFill>
-          <a:ln/>
-        </p:spPr>
-      </p:sp>
-      <p:sp>
-        <p:nvSpPr>
-          <p:cNvPr id="21" name="Text 19"/>
-          <p:cNvSpPr/>
-          <p:nvPr/>
-        </p:nvSpPr>
-        <p:spPr>
-          <a:xfrm>
-            <a:off x="5120640" y="3246120"/>
-            <a:ext cx="3474720" cy="365760"/>
-          </a:xfrm>
-          <a:prstGeom prst="rect">
-            <a:avLst/>
-          </a:prstGeom>
-          <a:noFill/>
-          <a:ln/>
-        </p:spPr>
-        <p:txBody>
-          <a:bodyPr wrap="square" lIns="0" tIns="0" rIns="0" bIns="0" rtlCol="0" anchor="ctr"/>
-          <a:lstStyle/>
-          <a:p>
-            <a:pPr algn="l" indent="0" marL="0">
-              <a:buNone/>
-            </a:pPr>
-            <a:r>
-              <a:rPr lang="en-US" sz="1300" b="1" dirty="0">
-                <a:solidFill>
-                  <a:srgbClr val="FFFFFF"/>
-                </a:solidFill>
-                <a:latin typeface="Cambria" pitchFamily="34" charset="0"/>
-                <a:ea typeface="Cambria" pitchFamily="34" charset="-122"/>
-                <a:cs typeface="Cambria" pitchFamily="34" charset="-120"/>
-              </a:rPr>
-              <a:t>Better Long-Term Value</a:t>
-            </a:r>
-            <a:endParaRPr lang="en-US" sz="1300" dirty="0"/>
-          </a:p>
-        </p:txBody>
-      </p:sp>
-      <p:sp>
-        <p:nvSpPr>
-          <p:cNvPr id="22" name="Text 20"/>
-          <p:cNvSpPr/>
-          <p:nvPr/>
-        </p:nvSpPr>
-        <p:spPr>
-          <a:xfrm>
-            <a:off x="5120640" y="3611880"/>
-            <a:ext cx="3474720" cy="457200"/>
-          </a:xfrm>
-          <a:prstGeom prst="rect">
-            <a:avLst/>
-          </a:prstGeom>
-          <a:noFill/>
-          <a:ln/>
-        </p:spPr>
-        <p:txBody>
-          <a:bodyPr wrap="square" lIns="0" tIns="0" rIns="0" bIns="0" rtlCol="0" anchor="ctr"/>
-          <a:lstStyle/>
-          <a:p>
-            <a:pPr algn="l" indent="0" marL="0">
-              <a:lnSpc>
-                <a:spcPct val="130000"/>
-              </a:lnSpc>
-              <a:buNone/>
-            </a:pPr>
-            <a:r>
-              <a:rPr lang="en-US" sz="1000" dirty="0">
-                <a:solidFill>
-                  <a:srgbClr val="9CA3AF"/>
-                </a:solidFill>
-                <a:latin typeface="Calibri" pitchFamily="34" charset="0"/>
-                <a:ea typeface="Calibri" pitchFamily="34" charset="-122"/>
-                <a:cs typeface="Calibri" pitchFamily="34" charset="-120"/>
-              </a:rPr>
-              <a:t>Remains useful as a corporate digital asset beyond gateway requirement</a:t>
-            </a:r>
-            <a:endParaRPr lang="en-US" sz="1000" dirty="0"/>
-          </a:p>
-        </p:txBody>
-      </p:sp>
-      <p:sp>
-        <p:nvSpPr>
-          <p:cNvPr id="23" name="Shape 21"/>
-          <p:cNvSpPr/>
-          <p:nvPr/>
-        </p:nvSpPr>
-        <p:spPr>
-          <a:xfrm>
-            <a:off x="457200" y="4526280"/>
-            <a:ext cx="2743200" cy="18288"/>
-          </a:xfrm>
-          <a:prstGeom prst="rect">
-            <a:avLst/>
-          </a:prstGeom>
-          <a:solidFill>
-            <a:srgbClr val="D4A853"/>
-          </a:solidFill>
-          <a:ln/>
-        </p:spPr>
-      </p:sp>
-      <p:sp>
-        <p:nvSpPr>
-          <p:cNvPr id="24" name="Text 22"/>
-          <p:cNvSpPr/>
-          <p:nvPr/>
-        </p:nvSpPr>
-        <p:spPr>
-          <a:xfrm>
-            <a:off x="457200" y="4617720"/>
-            <a:ext cx="8229600" cy="182880"/>
-          </a:xfrm>
-          <a:prstGeom prst="rect">
-            <a:avLst/>
-          </a:prstGeom>
-          <a:noFill/>
-          <a:ln/>
-        </p:spPr>
-        <p:txBody>
-          <a:bodyPr wrap="square" lIns="0" tIns="0" rIns="0" bIns="0" rtlCol="0" anchor="ctr"/>
-          <a:lstStyle/>
-          <a:p>
-            <a:pPr algn="l" indent="0" marL="0">
-              <a:buNone/>
-            </a:pPr>
-            <a:r>
-              <a:rPr lang="en-US" sz="800" b="1" spc="150" kern="0" dirty="0">
-                <a:solidFill>
-                  <a:srgbClr val="D4A853"/>
-                </a:solidFill>
-                <a:latin typeface="Calibri" pitchFamily="34" charset="0"/>
-                <a:ea typeface="Calibri" pitchFamily="34" charset="-122"/>
-                <a:cs typeface="Calibri" pitchFamily="34" charset="-120"/>
-              </a:rPr>
-              <a:t>OUR APPROACH</a:t>
-            </a:r>
-            <a:endParaRPr lang="en-US" sz="800" dirty="0"/>
-          </a:p>
-        </p:txBody>
-      </p:sp>
-      <p:sp>
-        <p:nvSpPr>
-          <p:cNvPr id="25" name="Text 23"/>
-          <p:cNvSpPr/>
-          <p:nvPr/>
-        </p:nvSpPr>
-        <p:spPr>
-          <a:xfrm>
-            <a:off x="457200" y="4800600"/>
-            <a:ext cx="8229600" cy="274320"/>
-          </a:xfrm>
-          <a:prstGeom prst="rect">
-            <a:avLst/>
-          </a:prstGeom>
-          <a:noFill/>
-          <a:ln/>
-        </p:spPr>
-        <p:txBody>
-          <a:bodyPr wrap="square" lIns="0" tIns="0" rIns="0" bIns="0" rtlCol="0" anchor="ctr"/>
-          <a:lstStyle/>
-          <a:p>
-            <a:pPr algn="l" indent="0" marL="0">
-              <a:buNone/>
-            </a:pPr>
-            <a:r>
-              <a:rPr lang="en-US" sz="1000" dirty="0">
-                <a:solidFill>
-                  <a:srgbClr val="9CA3AF"/>
-                </a:solidFill>
-                <a:latin typeface="Calibri" pitchFamily="34" charset="0"/>
-                <a:ea typeface="Calibri" pitchFamily="34" charset="-122"/>
-                <a:cs typeface="Calibri" pitchFamily="34" charset="-120"/>
-              </a:rPr>
-              <a:t>A modern, premium corporate website with clear business positioning and accurate information — not simply modifying or hiding the existing Casino Pride identity.</a:t>
-            </a:r>
-            <a:endParaRPr lang="en-US" sz="1000" dirty="0"/>
+              <a:rPr lang="en-US" sz="1050" dirty="0">
+                <a:solidFill>
+                  <a:srgbClr val="065F46"/>
+                </a:solidFill>
+                <a:latin typeface="Calibri" pitchFamily="34" charset="0"/>
+                <a:ea typeface="Calibri" pitchFamily="34" charset="-122"/>
+                <a:cs typeface="Calibri" pitchFamily="34" charset="-120"/>
+              </a:rPr>
+              <a:t>This creates a stronger corporate digital identity that can accommodate the company’s existing and future business activities, rather than creating a website solely around one entertainment brand.</a:t>
+            </a:r>
+            <a:endParaRPr lang="en-US" sz="1050" dirty="0"/>
           </a:p>
         </p:txBody>
       </p:sp>
@@ -4839,7 +4835,7 @@
     <p:bg>
       <p:bgPr>
         <a:solidFill>
-          <a:srgbClr val="F8FAFC"/>
+          <a:srgbClr val="F8FAF9"/>
         </a:solidFill>
       </p:bgPr>
     </p:bg>
@@ -4874,7 +4870,7 @@
             </a:avLst>
           </a:prstGeom>
           <a:solidFill>
-            <a:srgbClr val="0A0E1A"/>
+            <a:srgbClr val="0D7C5F"/>
           </a:solidFill>
           <a:ln/>
         </p:spPr>
@@ -4965,14 +4961,14 @@
         </p:nvSpPr>
         <p:spPr>
           <a:xfrm>
-            <a:off x="457200" y="1463040"/>
+            <a:off x="457200" y="1453896"/>
             <a:ext cx="182880" cy="182880"/>
           </a:xfrm>
           <a:prstGeom prst="ellipse">
             <a:avLst/>
           </a:prstGeom>
           <a:solidFill>
-            <a:srgbClr val="10B981"/>
+            <a:srgbClr val="0D7C5F"/>
           </a:solidFill>
           <a:ln/>
         </p:spPr>
@@ -4985,7 +4981,7 @@
         </p:nvSpPr>
         <p:spPr>
           <a:xfrm>
-            <a:off x="457200" y="1444752"/>
+            <a:off x="457200" y="1435608"/>
             <a:ext cx="182880" cy="201168"/>
           </a:xfrm>
           <a:prstGeom prst="rect">
@@ -5063,14 +5059,14 @@
         </p:nvSpPr>
         <p:spPr>
           <a:xfrm>
-            <a:off x="457200" y="1847088"/>
+            <a:off x="457200" y="1837944"/>
             <a:ext cx="182880" cy="182880"/>
           </a:xfrm>
           <a:prstGeom prst="ellipse">
             <a:avLst/>
           </a:prstGeom>
           <a:solidFill>
-            <a:srgbClr val="10B981"/>
+            <a:srgbClr val="0D7C5F"/>
           </a:solidFill>
           <a:ln/>
         </p:spPr>
@@ -5083,7 +5079,7 @@
         </p:nvSpPr>
         <p:spPr>
           <a:xfrm>
-            <a:off x="457200" y="1828800"/>
+            <a:off x="457200" y="1819656"/>
             <a:ext cx="182880" cy="201168"/>
           </a:xfrm>
           <a:prstGeom prst="rect">
@@ -5161,14 +5157,14 @@
         </p:nvSpPr>
         <p:spPr>
           <a:xfrm>
-            <a:off x="457200" y="2231136"/>
+            <a:off x="457200" y="2221992"/>
             <a:ext cx="182880" cy="182880"/>
           </a:xfrm>
           <a:prstGeom prst="ellipse">
             <a:avLst/>
           </a:prstGeom>
           <a:solidFill>
-            <a:srgbClr val="10B981"/>
+            <a:srgbClr val="0D7C5F"/>
           </a:solidFill>
           <a:ln/>
         </p:spPr>
@@ -5181,7 +5177,7 @@
         </p:nvSpPr>
         <p:spPr>
           <a:xfrm>
-            <a:off x="457200" y="2212848"/>
+            <a:off x="457200" y="2203704"/>
             <a:ext cx="182880" cy="201168"/>
           </a:xfrm>
           <a:prstGeom prst="rect">
@@ -5259,14 +5255,14 @@
         </p:nvSpPr>
         <p:spPr>
           <a:xfrm>
-            <a:off x="457200" y="2615184"/>
+            <a:off x="457200" y="2606040"/>
             <a:ext cx="182880" cy="182880"/>
           </a:xfrm>
           <a:prstGeom prst="ellipse">
             <a:avLst/>
           </a:prstGeom>
           <a:solidFill>
-            <a:srgbClr val="10B981"/>
+            <a:srgbClr val="0D7C5F"/>
           </a:solidFill>
           <a:ln/>
         </p:spPr>
@@ -5279,7 +5275,7 @@
         </p:nvSpPr>
         <p:spPr>
           <a:xfrm>
-            <a:off x="457200" y="2596896"/>
+            <a:off x="457200" y="2587752"/>
             <a:ext cx="182880" cy="201168"/>
           </a:xfrm>
           <a:prstGeom prst="rect">
@@ -5357,14 +5353,14 @@
         </p:nvSpPr>
         <p:spPr>
           <a:xfrm>
-            <a:off x="457200" y="2999232"/>
+            <a:off x="457200" y="2990088"/>
             <a:ext cx="182880" cy="182880"/>
           </a:xfrm>
           <a:prstGeom prst="ellipse">
             <a:avLst/>
           </a:prstGeom>
           <a:solidFill>
-            <a:srgbClr val="10B981"/>
+            <a:srgbClr val="0D7C5F"/>
           </a:solidFill>
           <a:ln/>
         </p:spPr>
@@ -5377,7 +5373,7 @@
         </p:nvSpPr>
         <p:spPr>
           <a:xfrm>
-            <a:off x="457200" y="2980944"/>
+            <a:off x="457200" y="2971800"/>
             <a:ext cx="182880" cy="201168"/>
           </a:xfrm>
           <a:prstGeom prst="rect">
@@ -5455,14 +5451,14 @@
         </p:nvSpPr>
         <p:spPr>
           <a:xfrm>
-            <a:off x="3017520" y="1463040"/>
+            <a:off x="3017520" y="1453896"/>
             <a:ext cx="182880" cy="182880"/>
           </a:xfrm>
           <a:prstGeom prst="ellipse">
             <a:avLst/>
           </a:prstGeom>
           <a:solidFill>
-            <a:srgbClr val="10B981"/>
+            <a:srgbClr val="0D7C5F"/>
           </a:solidFill>
           <a:ln/>
         </p:spPr>
@@ -5475,7 +5471,7 @@
         </p:nvSpPr>
         <p:spPr>
           <a:xfrm>
-            <a:off x="3017520" y="1444752"/>
+            <a:off x="3017520" y="1435608"/>
             <a:ext cx="182880" cy="201168"/>
           </a:xfrm>
           <a:prstGeom prst="rect">
@@ -5553,14 +5549,14 @@
         </p:nvSpPr>
         <p:spPr>
           <a:xfrm>
-            <a:off x="3017520" y="1847088"/>
+            <a:off x="3017520" y="1837944"/>
             <a:ext cx="182880" cy="182880"/>
           </a:xfrm>
           <a:prstGeom prst="ellipse">
             <a:avLst/>
           </a:prstGeom>
           <a:solidFill>
-            <a:srgbClr val="10B981"/>
+            <a:srgbClr val="0D7C5F"/>
           </a:solidFill>
           <a:ln/>
         </p:spPr>
@@ -5573,7 +5569,7 @@
         </p:nvSpPr>
         <p:spPr>
           <a:xfrm>
-            <a:off x="3017520" y="1828800"/>
+            <a:off x="3017520" y="1819656"/>
             <a:ext cx="182880" cy="201168"/>
           </a:xfrm>
           <a:prstGeom prst="rect">
@@ -5651,14 +5647,14 @@
         </p:nvSpPr>
         <p:spPr>
           <a:xfrm>
-            <a:off x="3017520" y="2231136"/>
+            <a:off x="3017520" y="2221992"/>
             <a:ext cx="182880" cy="182880"/>
           </a:xfrm>
           <a:prstGeom prst="ellipse">
             <a:avLst/>
           </a:prstGeom>
           <a:solidFill>
-            <a:srgbClr val="10B981"/>
+            <a:srgbClr val="0D7C5F"/>
           </a:solidFill>
           <a:ln/>
         </p:spPr>
@@ -5671,7 +5667,7 @@
         </p:nvSpPr>
         <p:spPr>
           <a:xfrm>
-            <a:off x="3017520" y="2212848"/>
+            <a:off x="3017520" y="2203704"/>
             <a:ext cx="182880" cy="201168"/>
           </a:xfrm>
           <a:prstGeom prst="rect">
@@ -5749,14 +5745,14 @@
         </p:nvSpPr>
         <p:spPr>
           <a:xfrm>
-            <a:off x="3017520" y="2615184"/>
+            <a:off x="3017520" y="2606040"/>
             <a:ext cx="182880" cy="182880"/>
           </a:xfrm>
           <a:prstGeom prst="ellipse">
             <a:avLst/>
           </a:prstGeom>
           <a:solidFill>
-            <a:srgbClr val="10B981"/>
+            <a:srgbClr val="0D7C5F"/>
           </a:solidFill>
           <a:ln/>
         </p:spPr>
@@ -5769,7 +5765,7 @@
         </p:nvSpPr>
         <p:spPr>
           <a:xfrm>
-            <a:off x="3017520" y="2596896"/>
+            <a:off x="3017520" y="2587752"/>
             <a:ext cx="182880" cy="201168"/>
           </a:xfrm>
           <a:prstGeom prst="rect">
@@ -5848,21 +5844,21 @@
         <p:spPr>
           <a:xfrm>
             <a:off x="5669280" y="777240"/>
-            <a:ext cx="3108960" cy="2926080"/>
+            <a:ext cx="3108960" cy="3017520"/>
           </a:xfrm>
           <a:prstGeom prst="roundRect">
             <a:avLst>
-              <a:gd name="adj" fmla="val 4688"/>
+              <a:gd name="adj" fmla="val 4545"/>
             </a:avLst>
           </a:prstGeom>
           <a:solidFill>
-            <a:srgbClr val="0A0E1A"/>
+            <a:srgbClr val="0D7C5F"/>
           </a:solidFill>
           <a:ln/>
           <a:effectLst>
-            <a:outerShdw sx="100000" sy="100000" kx="0" ky="0" algn="bl" rotWithShape="0" blurRad="152400" dist="50800" dir="16200000">
+            <a:outerShdw sx="100000" sy="100000" kx="0" ky="0" algn="bl" rotWithShape="0" blurRad="127000" dist="38100" dir="16200000">
               <a:srgbClr val="000000">
-                <a:alpha val="20000"/>
+                <a:alpha val="15000"/>
               </a:srgbClr>
             </a:outerShdw>
           </a:effectLst>
@@ -5885,7 +5881,7 @@
             </a:avLst>
           </a:prstGeom>
           <a:solidFill>
-            <a:srgbClr val="D4A853"/>
+            <a:srgbClr val="6EE7B7"/>
           </a:solidFill>
           <a:ln/>
         </p:spPr>
@@ -5917,7 +5913,7 @@
             <a:r>
               <a:rPr lang="en-US" sz="1100" dirty="0">
                 <a:solidFill>
-                  <a:srgbClr val="9CA3AF"/>
+                  <a:srgbClr val="D1FAE5"/>
                 </a:solidFill>
                 <a:latin typeface="Calibri" pitchFamily="34" charset="0"/>
                 <a:ea typeface="Calibri" pitchFamily="34" charset="-122"/>
@@ -5956,7 +5952,7 @@
             <a:r>
               <a:rPr lang="en-US" sz="1300" strike="sngStrike" dirty="0">
                 <a:solidFill>
-                  <a:srgbClr val="6B7280"/>
+                  <a:srgbClr val="6EE7B7"/>
                 </a:solidFill>
                 <a:latin typeface="Calibri" pitchFamily="34" charset="0"/>
                 <a:ea typeface="Calibri" pitchFamily="34" charset="-122"/>
@@ -6015,7 +6011,7 @@
         </p:nvSpPr>
         <p:spPr>
           <a:xfrm>
-            <a:off x="7818120" y="1965960"/>
+            <a:off x="7772400" y="1965960"/>
             <a:ext cx="731520" cy="274320"/>
           </a:xfrm>
           <a:prstGeom prst="rect">
@@ -6034,7 +6030,7 @@
             <a:r>
               <a:rPr lang="en-US" sz="1000" dirty="0">
                 <a:solidFill>
-                  <a:srgbClr val="9CA3AF"/>
+                  <a:srgbClr val="D1FAE5"/>
                 </a:solidFill>
                 <a:latin typeface="Calibri" pitchFamily="34" charset="0"/>
                 <a:ea typeface="Calibri" pitchFamily="34" charset="-122"/>
@@ -6061,7 +6057,7 @@
             <a:avLst/>
           </a:prstGeom>
           <a:solidFill>
-            <a:srgbClr val="1C2438"/>
+            <a:srgbClr val="065F46"/>
           </a:solidFill>
           <a:ln/>
         </p:spPr>
@@ -6093,7 +6089,7 @@
             <a:r>
               <a:rPr lang="en-US" sz="900" dirty="0">
                 <a:solidFill>
-                  <a:srgbClr val="9CA3AF"/>
+                  <a:srgbClr val="D1FAE5"/>
                 </a:solidFill>
                 <a:latin typeface="Calibri" pitchFamily="34" charset="0"/>
                 <a:ea typeface="Calibri" pitchFamily="34" charset="-122"/>
@@ -6132,7 +6128,7 @@
             <a:r>
               <a:rPr lang="en-US" sz="900" dirty="0">
                 <a:solidFill>
-                  <a:srgbClr val="9CA3AF"/>
+                  <a:srgbClr val="D1FAE5"/>
                 </a:solidFill>
                 <a:latin typeface="Calibri" pitchFamily="34" charset="0"/>
                 <a:ea typeface="Calibri" pitchFamily="34" charset="-122"/>
@@ -6161,7 +6157,7 @@
             </a:avLst>
           </a:prstGeom>
           <a:solidFill>
-            <a:srgbClr val="D4A853"/>
+            <a:srgbClr val="FFFFFF"/>
           </a:solidFill>
           <a:ln/>
         </p:spPr>
@@ -6193,7 +6189,7 @@
             <a:r>
               <a:rPr lang="en-US" sz="1600" b="1" dirty="0">
                 <a:solidFill>
-                  <a:srgbClr val="0A0E1A"/>
+                  <a:srgbClr val="0D7C5F"/>
                 </a:solidFill>
                 <a:latin typeface="Cambria" pitchFamily="34" charset="0"/>
                 <a:ea typeface="Cambria" pitchFamily="34" charset="-122"/>
@@ -6222,7 +6218,7 @@
             </a:avLst>
           </a:prstGeom>
           <a:solidFill>
-            <a:srgbClr val="064E3B"/>
+            <a:srgbClr val="065F46"/>
           </a:solidFill>
           <a:ln/>
         </p:spPr>
@@ -6254,7 +6250,7 @@
             <a:r>
               <a:rPr lang="en-US" sz="800" b="1" dirty="0">
                 <a:solidFill>
-                  <a:srgbClr val="10B981"/>
+                  <a:srgbClr val="FFFFFF"/>
                 </a:solidFill>
                 <a:latin typeface="Calibri" pitchFamily="34" charset="0"/>
                 <a:ea typeface="Calibri" pitchFamily="34" charset="-122"/>
@@ -6287,9 +6283,9 @@
           </a:solidFill>
           <a:ln/>
           <a:effectLst>
-            <a:outerShdw sx="100000" sy="100000" kx="0" ky="0" algn="bl" rotWithShape="0" blurRad="76200" dist="25400" dir="16200000">
+            <a:outerShdw sx="100000" sy="100000" kx="0" ky="0" algn="bl" rotWithShape="0" blurRad="63500" dist="25400" dir="16200000">
               <a:srgbClr val="000000">
-                <a:alpha val="6000"/>
+                <a:alpha val="5000"/>
               </a:srgbClr>
             </a:outerShdw>
           </a:effectLst>
@@ -6322,7 +6318,7 @@
             <a:r>
               <a:rPr lang="en-US" sz="800" b="1" spc="150" kern="0" dirty="0">
                 <a:solidFill>
-                  <a:srgbClr val="0A0E1A"/>
+                  <a:srgbClr val="0D7C5F"/>
                 </a:solidFill>
                 <a:latin typeface="Calibri" pitchFamily="34" charset="0"/>
                 <a:ea typeface="Calibri" pitchFamily="34" charset="-122"/>
@@ -6351,7 +6347,7 @@
             </a:avLst>
           </a:prstGeom>
           <a:solidFill>
-            <a:srgbClr val="0A0E1A"/>
+            <a:srgbClr val="0D7C5F"/>
           </a:solidFill>
           <a:ln/>
         </p:spPr>

</xml_diff>